<commit_message>
Add unit-value spec-change slide (16-slide deck)
</commit_message>
<xml_diff>
--- a/第52期売上分析/第51期見込と第52期計画について_20260905（部門長会議用）.pptx
+++ b/第52期売上分析/第51期見込と第52期計画について_20260905（部門長会議用）.pptx
@@ -15,6 +15,7 @@
     <p:sldId id="401" r:id="rId21"/>
     <p:sldId id="402" r:id="rId17"/>
     <p:sldId id="403" r:id="rId18"/>
+    <p:sldId id="406" r:id="rId15"/>
     <p:sldId id="382" r:id="rId8"/>
     <p:sldId id="379" r:id="rId9"/>
     <p:sldId id="383" r:id="rId10"/>
@@ -7085,6 +7086,629 @@
 </file>
 
 <file path=ppt/slides/slide10.xml><?xml version="1.0" encoding="utf-8"?>
+<p:sld xmlns:a="http://schemas.openxmlformats.org/drawingml/2006/main" xmlns:p="http://schemas.openxmlformats.org/presentationml/2006/main" xmlns:r="http://schemas.openxmlformats.org/officeDocument/2006/relationships">
+  <p:cSld>
+    <p:spTree>
+      <p:nvGrpSpPr>
+        <p:cNvPr id="1" name=""/>
+        <p:cNvGrpSpPr/>
+        <p:nvPr/>
+      </p:nvGrpSpPr>
+      <p:grpSpPr/>
+      <p:sp>
+        <p:nvSpPr>
+          <p:cNvPr id="2" name="Rectangle 1"/>
+          <p:cNvSpPr/>
+          <p:nvPr/>
+        </p:nvSpPr>
+        <p:spPr>
+          <a:xfrm>
+            <a:off x="0" y="0"/>
+            <a:ext cx="64008" cy="6858000"/>
+          </a:xfrm>
+          <a:prstGeom prst="rect">
+            <a:avLst/>
+          </a:prstGeom>
+          <a:solidFill>
+            <a:srgbClr val="B8860B"/>
+          </a:solidFill>
+          <a:ln>
+            <a:noFill/>
+          </a:ln>
+          <a:effectLst/>
+        </p:spPr>
+        <p:style>
+          <a:lnRef idx="1">
+            <a:schemeClr val="accent1"/>
+          </a:lnRef>
+          <a:fillRef idx="3">
+            <a:schemeClr val="accent1"/>
+          </a:fillRef>
+          <a:effectRef idx="2">
+            <a:schemeClr val="accent1"/>
+          </a:effectRef>
+          <a:fontRef idx="minor">
+            <a:schemeClr val="lt1"/>
+          </a:fontRef>
+        </p:style>
+        <p:txBody>
+          <a:bodyPr wrap="square" rtlCol="0" anchor="ctr"/>
+          <a:lstStyle/>
+          <a:p>
+            <a:pPr algn="ctr"/>
+            <a:endParaRPr/>
+          </a:p>
+        </p:txBody>
+      </p:sp>
+      <p:sp>
+        <p:nvSpPr>
+          <p:cNvPr id="3" name="Rectangle 2"/>
+          <p:cNvSpPr/>
+          <p:nvPr/>
+        </p:nvSpPr>
+        <p:spPr>
+          <a:xfrm>
+            <a:off x="0" y="0"/>
+            <a:ext cx="12191695" cy="877824"/>
+          </a:xfrm>
+          <a:prstGeom prst="rect">
+            <a:avLst/>
+          </a:prstGeom>
+          <a:solidFill>
+            <a:srgbClr val="1F3864"/>
+          </a:solidFill>
+          <a:ln>
+            <a:noFill/>
+          </a:ln>
+          <a:effectLst/>
+        </p:spPr>
+        <p:style>
+          <a:lnRef idx="1">
+            <a:schemeClr val="accent1"/>
+          </a:lnRef>
+          <a:fillRef idx="3">
+            <a:schemeClr val="accent1"/>
+          </a:fillRef>
+          <a:effectRef idx="2">
+            <a:schemeClr val="accent1"/>
+          </a:effectRef>
+          <a:fontRef idx="minor">
+            <a:schemeClr val="lt1"/>
+          </a:fontRef>
+        </p:style>
+        <p:txBody>
+          <a:bodyPr wrap="square" rtlCol="0" anchor="ctr"/>
+          <a:lstStyle/>
+          <a:p>
+            <a:pPr algn="ctr"/>
+            <a:endParaRPr/>
+          </a:p>
+        </p:txBody>
+      </p:sp>
+      <p:sp>
+        <p:nvSpPr>
+          <p:cNvPr id="4" name="TextBox 3"/>
+          <p:cNvSpPr txBox="1"/>
+          <p:nvPr/>
+        </p:nvSpPr>
+        <p:spPr>
+          <a:xfrm>
+            <a:off x="411480" y="109728"/>
+            <a:ext cx="2377440" cy="237744"/>
+          </a:xfrm>
+          <a:prstGeom prst="rect">
+            <a:avLst/>
+          </a:prstGeom>
+          <a:noFill/>
+        </p:spPr>
+        <p:txBody>
+          <a:bodyPr wrap="square" lIns="0" tIns="0" rIns="0" bIns="0" anchor="t">
+            <a:spAutoFit/>
+          </a:bodyPr>
+          <a:lstStyle/>
+          <a:p>
+            <a:pPr algn="l">
+              <a:spcAft>
+                <a:spcPts val="400"/>
+              </a:spcAft>
+            </a:pPr>
+            <a:r>
+              <a:rPr sz="950" b="1">
+                <a:solidFill>
+                  <a:srgbClr val="B8860B"/>
+                </a:solidFill>
+                <a:latin typeface="游ゴシック"/>
+              </a:rPr>
+              <a:t>第3章　当社の実績</a:t>
+            </a:r>
+          </a:p>
+        </p:txBody>
+      </p:sp>
+      <p:sp>
+        <p:nvSpPr>
+          <p:cNvPr id="5" name="TextBox 4"/>
+          <p:cNvSpPr txBox="1"/>
+          <p:nvPr/>
+        </p:nvSpPr>
+        <p:spPr>
+          <a:xfrm>
+            <a:off x="411480" y="310896"/>
+            <a:ext cx="10195560" cy="365760"/>
+          </a:xfrm>
+          <a:prstGeom prst="rect">
+            <a:avLst/>
+          </a:prstGeom>
+          <a:noFill/>
+        </p:spPr>
+        <p:txBody>
+          <a:bodyPr wrap="square" lIns="0" tIns="0" rIns="0" bIns="0" anchor="t">
+            <a:spAutoFit/>
+          </a:bodyPr>
+          <a:lstStyle/>
+          <a:p>
+            <a:pPr algn="l">
+              <a:spcAft>
+                <a:spcPts val="400"/>
+              </a:spcAft>
+            </a:pPr>
+            <a:r>
+              <a:rPr sz="2300" b="1">
+                <a:solidFill>
+                  <a:srgbClr val="FFFFFF"/>
+                </a:solidFill>
+                <a:latin typeface="游ゴシック"/>
+              </a:rPr>
+              <a:t>8月の売上増減の内訳 ―― 突合の外側にある「品目入替」【機械類を除く】</a:t>
+            </a:r>
+          </a:p>
+        </p:txBody>
+      </p:sp>
+      <p:sp>
+        <p:nvSpPr>
+          <p:cNvPr id="6" name="TextBox 5"/>
+          <p:cNvSpPr txBox="1"/>
+          <p:nvPr/>
+        </p:nvSpPr>
+        <p:spPr>
+          <a:xfrm>
+            <a:off x="429768" y="658368"/>
+            <a:ext cx="10195560" cy="219456"/>
+          </a:xfrm>
+          <a:prstGeom prst="rect">
+            <a:avLst/>
+          </a:prstGeom>
+          <a:noFill/>
+        </p:spPr>
+        <p:txBody>
+          <a:bodyPr wrap="square" lIns="0" tIns="0" rIns="0" bIns="0" anchor="t">
+            <a:spAutoFit/>
+          </a:bodyPr>
+          <a:lstStyle/>
+          <a:p>
+            <a:pPr algn="l">
+              <a:spcAft>
+                <a:spcPts val="400"/>
+              </a:spcAft>
+            </a:pPr>
+            <a:r>
+              <a:rPr sz="1050" b="0">
+                <a:solidFill>
+                  <a:srgbClr val="D6E4F0"/>
+                </a:solidFill>
+                <a:latin typeface="游ゴシック"/>
+              </a:rPr>
+              <a:t>突合できた品目は単価・数量に分解。突合できない品目（終売・新規・仕様変更で商品コードが変わったもの）は「品目入替」として別建て。単位：百万円</a:t>
+            </a:r>
+          </a:p>
+        </p:txBody>
+      </p:sp>
+      <p:sp>
+        <p:nvSpPr>
+          <p:cNvPr id="8" name="TextBox 7"/>
+          <p:cNvSpPr txBox="1"/>
+          <p:nvPr/>
+        </p:nvSpPr>
+        <p:spPr>
+          <a:xfrm>
+            <a:off x="8259775" y="6473952"/>
+            <a:ext cx="3566160" cy="237744"/>
+          </a:xfrm>
+          <a:prstGeom prst="rect">
+            <a:avLst/>
+          </a:prstGeom>
+          <a:noFill/>
+        </p:spPr>
+        <p:txBody>
+          <a:bodyPr wrap="square" lIns="0" tIns="0" rIns="0" bIns="0" anchor="t">
+            <a:spAutoFit/>
+          </a:bodyPr>
+          <a:lstStyle/>
+          <a:p>
+            <a:pPr algn="r">
+              <a:spcAft>
+                <a:spcPts val="400"/>
+              </a:spcAft>
+            </a:pPr>
+            <a:r>
+              <a:rPr sz="900" b="0">
+                <a:solidFill>
+                  <a:srgbClr val="8C8C8C"/>
+                </a:solidFill>
+                <a:latin typeface="游ゴシック"/>
+              </a:rPr>
+              <a:t>㈱タカハシ包装センター　社外秘　P10</a:t>
+            </a:r>
+          </a:p>
+        </p:txBody>
+      </p:sp>
+      <p:sp>
+        <p:nvSpPr>
+          <p:cNvPr id="10" name="TextBox 9"/>
+          <p:cNvSpPr txBox="1"/>
+          <p:nvPr/>
+        </p:nvSpPr>
+        <p:spPr>
+          <a:xfrm>
+            <a:off x="411480" y="6473952"/>
+            <a:ext cx="7863840" cy="237744"/>
+          </a:xfrm>
+          <a:prstGeom prst="rect">
+            <a:avLst/>
+          </a:prstGeom>
+          <a:noFill/>
+        </p:spPr>
+        <p:txBody>
+          <a:bodyPr wrap="square" lIns="0" tIns="0" rIns="0" bIns="0">
+            <a:spAutoFit/>
+          </a:bodyPr>
+          <a:lstStyle/>
+          <a:p>
+            <a:pPr algn="l"/>
+            <a:r>
+              <a:rPr sz="850" b="0">
+                <a:solidFill>
+                  <a:srgbClr val="8C8C8C"/>
+                </a:solidFill>
+                <a:latin typeface="游ゴシック"/>
+              </a:rPr>
+              <a:t>出所：2508・2608タカハシ包装売上全明細（機械類を除く）。突合対象外には単価が前年比0.25〜4.0倍の範囲外の品目（前年0.6・当年0.2百万円）を含む</a:t>
+            </a:r>
+          </a:p>
+        </p:txBody>
+      </p:sp>
+      <p:pic>
+        <p:nvPicPr>
+          <p:cNvPr id="11" name="Picture 10" descr="image.jpg"/>
+          <p:cNvPicPr>
+            <a:picLocks noChangeAspect="1"/>
+          </p:cNvPicPr>
+          <p:nvPr/>
+        </p:nvPicPr>
+        <p:blipFill>
+          <a:blip r:embed="rId2"/>
+          <a:stretch>
+            <a:fillRect/>
+          </a:stretch>
+        </p:blipFill>
+        <p:spPr>
+          <a:xfrm>
+            <a:off x="11259007" y="137160"/>
+            <a:ext cx="603504" cy="603504"/>
+          </a:xfrm>
+          <a:prstGeom prst="rect">
+            <a:avLst/>
+          </a:prstGeom>
+        </p:spPr>
+      </p:pic>
+      <p:graphicFrame>
+        <p:nvGraphicFramePr>
+          <p:cNvPr id="12" name="Chart 11"/>
+          <p:cNvGraphicFramePr>
+            <a:graphicFrameLocks noGrp="1"/>
+          </p:cNvGraphicFramePr>
+          <p:nvPr/>
+        </p:nvGraphicFramePr>
+        <p:xfrm>
+          <a:off x="411480" y="1143000"/>
+          <a:ext cx="6949440" cy="5120640"/>
+        </p:xfrm>
+        <a:graphic>
+          <a:graphicData uri="http://schemas.openxmlformats.org/drawingml/2006/chart">
+            <c:chart xmlns:c="http://schemas.openxmlformats.org/drawingml/2006/chart" r:id="rId3"/>
+          </a:graphicData>
+        </a:graphic>
+      </p:graphicFrame>
+      <p:sp>
+        <p:nvSpPr>
+          <p:cNvPr id="13" name="Rectangle 12"/>
+          <p:cNvSpPr/>
+          <p:nvPr/>
+        </p:nvSpPr>
+        <p:spPr>
+          <a:xfrm>
+            <a:off x="7589520" y="1143000"/>
+            <a:ext cx="4160520" cy="1600200"/>
+          </a:xfrm>
+          <a:prstGeom prst="rect">
+            <a:avLst/>
+          </a:prstGeom>
+          <a:solidFill>
+            <a:srgbClr val="F7F9FC"/>
+          </a:solidFill>
+          <a:ln>
+            <a:noFill/>
+          </a:ln>
+          <a:effectLst/>
+        </p:spPr>
+        <p:style>
+          <a:lnRef idx="1">
+            <a:schemeClr val="accent1"/>
+          </a:lnRef>
+          <a:fillRef idx="3">
+            <a:schemeClr val="accent1"/>
+          </a:fillRef>
+          <a:effectRef idx="2">
+            <a:schemeClr val="accent1"/>
+          </a:effectRef>
+          <a:fontRef idx="minor">
+            <a:schemeClr val="lt1"/>
+          </a:fontRef>
+        </p:style>
+        <p:txBody>
+          <a:bodyPr rtlCol="0" anchor="ctr"/>
+          <a:lstStyle/>
+          <a:p>
+            <a:pPr algn="ctr"/>
+          </a:p>
+        </p:txBody>
+      </p:sp>
+      <p:sp>
+        <p:nvSpPr>
+          <p:cNvPr id="14" name="TextBox 13"/>
+          <p:cNvSpPr txBox="1"/>
+          <p:nvPr/>
+        </p:nvSpPr>
+        <p:spPr>
+          <a:xfrm>
+            <a:off x="7726680" y="1216152"/>
+            <a:ext cx="3886200" cy="1453896"/>
+          </a:xfrm>
+          <a:prstGeom prst="rect">
+            <a:avLst/>
+          </a:prstGeom>
+          <a:noFill/>
+        </p:spPr>
+        <p:txBody>
+          <a:bodyPr wrap="square" lIns="0" rIns="0">
+            <a:spAutoFit/>
+          </a:bodyPr>
+          <a:lstStyle/>
+          <a:p>
+            <a:r>
+              <a:rPr sz="1200" b="1">
+                <a:solidFill>
+                  <a:srgbClr val="1F3864"/>
+                </a:solidFill>
+                <a:latin typeface="游ゴシック"/>
+              </a:rPr>
+              <a:t>「突合」＝同一商品コードどうしの比較</a:t>
+            </a:r>
+          </a:p>
+          <a:p>
+            <a:pPr>
+              <a:spcBef>
+                <a:spcPts val="400"/>
+              </a:spcBef>
+            </a:pPr>
+            <a:r>
+              <a:rPr sz="1000" b="0">
+                <a:solidFill>
+                  <a:srgbClr val="404040"/>
+                </a:solidFill>
+                <a:latin typeface="游ゴシック"/>
+              </a:rPr>
+              <a:t>単価寄与＋19.6％は、同じ商品が値上げされた効果。材質・色数などの仕様変更で商品コードが変わった品目（スペックダウンを含む）は突合できず、単価・数量には入らない。</a:t>
+            </a:r>
+          </a:p>
+        </p:txBody>
+      </p:sp>
+      <p:sp>
+        <p:nvSpPr>
+          <p:cNvPr id="15" name="Rectangle 14"/>
+          <p:cNvSpPr/>
+          <p:nvPr/>
+        </p:nvSpPr>
+        <p:spPr>
+          <a:xfrm>
+            <a:off x="7589520" y="2834640"/>
+            <a:ext cx="4160520" cy="1600200"/>
+          </a:xfrm>
+          <a:prstGeom prst="rect">
+            <a:avLst/>
+          </a:prstGeom>
+          <a:solidFill>
+            <a:srgbClr val="F7F9FC"/>
+          </a:solidFill>
+          <a:ln>
+            <a:noFill/>
+          </a:ln>
+          <a:effectLst/>
+        </p:spPr>
+        <p:style>
+          <a:lnRef idx="1">
+            <a:schemeClr val="accent1"/>
+          </a:lnRef>
+          <a:fillRef idx="3">
+            <a:schemeClr val="accent1"/>
+          </a:fillRef>
+          <a:effectRef idx="2">
+            <a:schemeClr val="accent1"/>
+          </a:effectRef>
+          <a:fontRef idx="minor">
+            <a:schemeClr val="lt1"/>
+          </a:fontRef>
+        </p:style>
+        <p:txBody>
+          <a:bodyPr rtlCol="0" anchor="ctr"/>
+          <a:lstStyle/>
+          <a:p>
+            <a:pPr algn="ctr"/>
+          </a:p>
+        </p:txBody>
+      </p:sp>
+      <p:sp>
+        <p:nvSpPr>
+          <p:cNvPr id="16" name="TextBox 15"/>
+          <p:cNvSpPr txBox="1"/>
+          <p:nvPr/>
+        </p:nvSpPr>
+        <p:spPr>
+          <a:xfrm>
+            <a:off x="7726680" y="2907792"/>
+            <a:ext cx="3886200" cy="1453896"/>
+          </a:xfrm>
+          <a:prstGeom prst="rect">
+            <a:avLst/>
+          </a:prstGeom>
+          <a:noFill/>
+        </p:spPr>
+        <p:txBody>
+          <a:bodyPr wrap="square" lIns="0" rIns="0">
+            <a:spAutoFit/>
+          </a:bodyPr>
+          <a:lstStyle/>
+          <a:p>
+            <a:r>
+              <a:rPr sz="1200" b="1">
+                <a:solidFill>
+                  <a:srgbClr val="C00000"/>
+                </a:solidFill>
+                <a:latin typeface="游ゴシック"/>
+              </a:rPr>
+              <a:t>品目入替は差し引き▲9.3百万円</a:t>
+            </a:r>
+          </a:p>
+          <a:p>
+            <a:pPr>
+              <a:spcBef>
+                <a:spcPts val="400"/>
+              </a:spcBef>
+            </a:pPr>
+            <a:r>
+              <a:rPr sz="1000" b="0">
+                <a:solidFill>
+                  <a:srgbClr val="404040"/>
+                </a:solidFill>
+                <a:latin typeface="游ゴシック"/>
+              </a:rPr>
+              <a:t>前年のみの品目79.9百万円が消え、当年のみの品目70.7百万円が入った。スペックダウン（単価引下げ）や安価品への切替の影響はここに含まれ、単価効果を打ち消す方向に働いている。</a:t>
+            </a:r>
+          </a:p>
+        </p:txBody>
+      </p:sp>
+      <p:sp>
+        <p:nvSpPr>
+          <p:cNvPr id="17" name="Rectangle 16"/>
+          <p:cNvSpPr/>
+          <p:nvPr/>
+        </p:nvSpPr>
+        <p:spPr>
+          <a:xfrm>
+            <a:off x="7589520" y="4526280"/>
+            <a:ext cx="4160520" cy="1737360"/>
+          </a:xfrm>
+          <a:prstGeom prst="rect">
+            <a:avLst/>
+          </a:prstGeom>
+          <a:solidFill>
+            <a:srgbClr val="F7F9FC"/>
+          </a:solidFill>
+          <a:ln>
+            <a:noFill/>
+          </a:ln>
+          <a:effectLst/>
+        </p:spPr>
+        <p:style>
+          <a:lnRef idx="1">
+            <a:schemeClr val="accent1"/>
+          </a:lnRef>
+          <a:fillRef idx="3">
+            <a:schemeClr val="accent1"/>
+          </a:fillRef>
+          <a:effectRef idx="2">
+            <a:schemeClr val="accent1"/>
+          </a:effectRef>
+          <a:fontRef idx="minor">
+            <a:schemeClr val="lt1"/>
+          </a:fontRef>
+        </p:style>
+        <p:txBody>
+          <a:bodyPr rtlCol="0" anchor="ctr"/>
+          <a:lstStyle/>
+          <a:p>
+            <a:pPr algn="ctr"/>
+          </a:p>
+        </p:txBody>
+      </p:sp>
+      <p:sp>
+        <p:nvSpPr>
+          <p:cNvPr id="18" name="TextBox 17"/>
+          <p:cNvSpPr txBox="1"/>
+          <p:nvPr/>
+        </p:nvSpPr>
+        <p:spPr>
+          <a:xfrm>
+            <a:off x="7726680" y="4599432"/>
+            <a:ext cx="3886200" cy="1591056"/>
+          </a:xfrm>
+          <a:prstGeom prst="rect">
+            <a:avLst/>
+          </a:prstGeom>
+          <a:noFill/>
+        </p:spPr>
+        <p:txBody>
+          <a:bodyPr wrap="square" lIns="0" rIns="0">
+            <a:spAutoFit/>
+          </a:bodyPr>
+          <a:lstStyle/>
+          <a:p>
+            <a:r>
+              <a:rPr sz="1200" b="1">
+                <a:solidFill>
+                  <a:srgbClr val="B8860B"/>
+                </a:solidFill>
+                <a:latin typeface="游ゴシック"/>
+              </a:rPr>
+              <a:t>計画に使うのは「全体」の伸び率</a:t>
+            </a:r>
+          </a:p>
+          <a:p>
+            <a:pPr>
+              <a:spcBef>
+                <a:spcPts val="400"/>
+              </a:spcBef>
+            </a:pPr>
+            <a:r>
+              <a:rPr sz="1000" b="0">
+                <a:solidFill>
+                  <a:srgbClr val="404040"/>
+                </a:solidFill>
+                <a:latin typeface="游ゴシック"/>
+              </a:rPr>
+              <a:t>突合ベースの＋17.0％をそのまま伸び率にすると過大。包装資材全体では＋7.5％で、これが計画の出発点。スペック変更の影響は次ページで分類別平均単価から確認する。</a:t>
+            </a:r>
+          </a:p>
+        </p:txBody>
+      </p:sp>
+    </p:spTree>
+  </p:cSld>
+  <p:clrMapOvr>
+    <a:masterClrMapping/>
+  </p:clrMapOvr>
+</p:sld>
+</file>
+
+<file path=ppt/slides/slide11.xml><?xml version="1.0" encoding="utf-8"?>
 <p:sld xmlns:a="http://schemas.openxmlformats.org/drawingml/2006/main" xmlns:r="http://schemas.openxmlformats.org/officeDocument/2006/relationships" xmlns:p="http://schemas.openxmlformats.org/presentationml/2006/main">
   <p:cSld>
     <p:spTree>
@@ -8350,7 +8974,7 @@
                 </a:solidFill>
                 <a:latin typeface="游ゴシック"/>
               </a:rPr>
-              <a:t>㈱タカハシ包装センター　社外秘　P11</a:t>
+              <a:t>㈱タカハシ包装センター　社外秘　P12</a:t>
             </a:r>
           </a:p>
         </p:txBody>
@@ -8969,7 +9593,7 @@
 </p:sld>
 </file>
 
-<file path=ppt/slides/slide11.xml><?xml version="1.0" encoding="utf-8"?>
+<file path=ppt/slides/slide12.xml><?xml version="1.0" encoding="utf-8"?>
 <p:sld xmlns:a="http://schemas.openxmlformats.org/drawingml/2006/main" xmlns:r="http://schemas.openxmlformats.org/officeDocument/2006/relationships" xmlns:p="http://schemas.openxmlformats.org/presentationml/2006/main">
   <p:cSld>
     <p:spTree>
@@ -9275,7 +9899,7 @@
                 </a:solidFill>
                 <a:latin typeface="游ゴシック"/>
               </a:rPr>
-              <a:t>㈱タカハシ包装センター　社外秘　P12</a:t>
+              <a:t>㈱タカハシ包装センター　社外秘　P13</a:t>
             </a:r>
           </a:p>
         </p:txBody>
@@ -10168,7 +10792,7 @@
 </p:sld>
 </file>
 
-<file path=ppt/slides/slide12.xml><?xml version="1.0" encoding="utf-8"?>
+<file path=ppt/slides/slide13.xml><?xml version="1.0" encoding="utf-8"?>
 <p:sld xmlns:a="http://schemas.openxmlformats.org/drawingml/2006/main" xmlns:r="http://schemas.openxmlformats.org/officeDocument/2006/relationships" xmlns:p="http://schemas.openxmlformats.org/presentationml/2006/main">
   <p:cSld>
     <p:spTree>
@@ -10602,7 +11226,7 @@
                 </a:solidFill>
                 <a:latin typeface="游ゴシック"/>
               </a:rPr>
-              <a:t>㈱タカハシ包装センター　社外秘　P13</a:t>
+              <a:t>㈱タカハシ包装センター　社外秘　P14</a:t>
             </a:r>
           </a:p>
         </p:txBody>
@@ -17603,629 +18227,6 @@
 </p:sld>
 </file>
 
-<file path=ppt/slides/slide13.xml><?xml version="1.0" encoding="utf-8"?>
-<p:sld xmlns:a="http://schemas.openxmlformats.org/drawingml/2006/main" xmlns:p="http://schemas.openxmlformats.org/presentationml/2006/main" xmlns:r="http://schemas.openxmlformats.org/officeDocument/2006/relationships">
-  <p:cSld>
-    <p:spTree>
-      <p:nvGrpSpPr>
-        <p:cNvPr id="1" name=""/>
-        <p:cNvGrpSpPr/>
-        <p:nvPr/>
-      </p:nvGrpSpPr>
-      <p:grpSpPr/>
-      <p:sp>
-        <p:nvSpPr>
-          <p:cNvPr id="2" name="Rectangle 1"/>
-          <p:cNvSpPr/>
-          <p:nvPr/>
-        </p:nvSpPr>
-        <p:spPr>
-          <a:xfrm>
-            <a:off x="0" y="0"/>
-            <a:ext cx="64008" cy="6858000"/>
-          </a:xfrm>
-          <a:prstGeom prst="rect">
-            <a:avLst/>
-          </a:prstGeom>
-          <a:solidFill>
-            <a:srgbClr val="B8860B"/>
-          </a:solidFill>
-          <a:ln>
-            <a:noFill/>
-          </a:ln>
-          <a:effectLst/>
-        </p:spPr>
-        <p:style>
-          <a:lnRef idx="1">
-            <a:schemeClr val="accent1"/>
-          </a:lnRef>
-          <a:fillRef idx="3">
-            <a:schemeClr val="accent1"/>
-          </a:fillRef>
-          <a:effectRef idx="2">
-            <a:schemeClr val="accent1"/>
-          </a:effectRef>
-          <a:fontRef idx="minor">
-            <a:schemeClr val="lt1"/>
-          </a:fontRef>
-        </p:style>
-        <p:txBody>
-          <a:bodyPr wrap="square" rtlCol="0" anchor="ctr"/>
-          <a:lstStyle/>
-          <a:p>
-            <a:pPr algn="ctr"/>
-            <a:endParaRPr/>
-          </a:p>
-        </p:txBody>
-      </p:sp>
-      <p:sp>
-        <p:nvSpPr>
-          <p:cNvPr id="3" name="Rectangle 2"/>
-          <p:cNvSpPr/>
-          <p:nvPr/>
-        </p:nvSpPr>
-        <p:spPr>
-          <a:xfrm>
-            <a:off x="0" y="0"/>
-            <a:ext cx="12191695" cy="877824"/>
-          </a:xfrm>
-          <a:prstGeom prst="rect">
-            <a:avLst/>
-          </a:prstGeom>
-          <a:solidFill>
-            <a:srgbClr val="1F3864"/>
-          </a:solidFill>
-          <a:ln>
-            <a:noFill/>
-          </a:ln>
-          <a:effectLst/>
-        </p:spPr>
-        <p:style>
-          <a:lnRef idx="1">
-            <a:schemeClr val="accent1"/>
-          </a:lnRef>
-          <a:fillRef idx="3">
-            <a:schemeClr val="accent1"/>
-          </a:fillRef>
-          <a:effectRef idx="2">
-            <a:schemeClr val="accent1"/>
-          </a:effectRef>
-          <a:fontRef idx="minor">
-            <a:schemeClr val="lt1"/>
-          </a:fontRef>
-        </p:style>
-        <p:txBody>
-          <a:bodyPr wrap="square" rtlCol="0" anchor="ctr"/>
-          <a:lstStyle/>
-          <a:p>
-            <a:pPr algn="ctr"/>
-            <a:endParaRPr/>
-          </a:p>
-        </p:txBody>
-      </p:sp>
-      <p:sp>
-        <p:nvSpPr>
-          <p:cNvPr id="4" name="TextBox 3"/>
-          <p:cNvSpPr txBox="1"/>
-          <p:nvPr/>
-        </p:nvSpPr>
-        <p:spPr>
-          <a:xfrm>
-            <a:off x="411480" y="109728"/>
-            <a:ext cx="2377440" cy="237744"/>
-          </a:xfrm>
-          <a:prstGeom prst="rect">
-            <a:avLst/>
-          </a:prstGeom>
-          <a:noFill/>
-        </p:spPr>
-        <p:txBody>
-          <a:bodyPr wrap="square" lIns="0" tIns="0" rIns="0" bIns="0" anchor="t">
-            <a:spAutoFit/>
-          </a:bodyPr>
-          <a:lstStyle/>
-          <a:p>
-            <a:pPr algn="l">
-              <a:spcAft>
-                <a:spcPts val="400"/>
-              </a:spcAft>
-            </a:pPr>
-            <a:r>
-              <a:rPr sz="950" b="1">
-                <a:solidFill>
-                  <a:srgbClr val="B8860B"/>
-                </a:solidFill>
-                <a:latin typeface="游ゴシック"/>
-              </a:rPr>
-              <a:t>第3章　当社の実績</a:t>
-            </a:r>
-          </a:p>
-        </p:txBody>
-      </p:sp>
-      <p:sp>
-        <p:nvSpPr>
-          <p:cNvPr id="5" name="TextBox 4"/>
-          <p:cNvSpPr txBox="1"/>
-          <p:nvPr/>
-        </p:nvSpPr>
-        <p:spPr>
-          <a:xfrm>
-            <a:off x="411480" y="310896"/>
-            <a:ext cx="10195560" cy="365760"/>
-          </a:xfrm>
-          <a:prstGeom prst="rect">
-            <a:avLst/>
-          </a:prstGeom>
-          <a:noFill/>
-        </p:spPr>
-        <p:txBody>
-          <a:bodyPr wrap="square" lIns="0" tIns="0" rIns="0" bIns="0" anchor="t">
-            <a:spAutoFit/>
-          </a:bodyPr>
-          <a:lstStyle/>
-          <a:p>
-            <a:pPr algn="l">
-              <a:spcAft>
-                <a:spcPts val="400"/>
-              </a:spcAft>
-            </a:pPr>
-            <a:r>
-              <a:rPr sz="2300" b="1">
-                <a:solidFill>
-                  <a:srgbClr val="FFFFFF"/>
-                </a:solidFill>
-                <a:latin typeface="游ゴシック"/>
-              </a:rPr>
-              <a:t>8月の売上増減の内訳 ―― 突合の外側にある「品目入替」【機械類を除く】</a:t>
-            </a:r>
-          </a:p>
-        </p:txBody>
-      </p:sp>
-      <p:sp>
-        <p:nvSpPr>
-          <p:cNvPr id="6" name="TextBox 5"/>
-          <p:cNvSpPr txBox="1"/>
-          <p:nvPr/>
-        </p:nvSpPr>
-        <p:spPr>
-          <a:xfrm>
-            <a:off x="429768" y="658368"/>
-            <a:ext cx="10195560" cy="219456"/>
-          </a:xfrm>
-          <a:prstGeom prst="rect">
-            <a:avLst/>
-          </a:prstGeom>
-          <a:noFill/>
-        </p:spPr>
-        <p:txBody>
-          <a:bodyPr wrap="square" lIns="0" tIns="0" rIns="0" bIns="0" anchor="t">
-            <a:spAutoFit/>
-          </a:bodyPr>
-          <a:lstStyle/>
-          <a:p>
-            <a:pPr algn="l">
-              <a:spcAft>
-                <a:spcPts val="400"/>
-              </a:spcAft>
-            </a:pPr>
-            <a:r>
-              <a:rPr sz="1050" b="0">
-                <a:solidFill>
-                  <a:srgbClr val="D6E4F0"/>
-                </a:solidFill>
-                <a:latin typeface="游ゴシック"/>
-              </a:rPr>
-              <a:t>突合できた品目は単価・数量に分解。突合できない品目（終売・新規・仕様変更で商品コードが変わったもの）は「品目入替」として別建て。単位：百万円</a:t>
-            </a:r>
-          </a:p>
-        </p:txBody>
-      </p:sp>
-      <p:sp>
-        <p:nvSpPr>
-          <p:cNvPr id="8" name="TextBox 7"/>
-          <p:cNvSpPr txBox="1"/>
-          <p:nvPr/>
-        </p:nvSpPr>
-        <p:spPr>
-          <a:xfrm>
-            <a:off x="8259775" y="6473952"/>
-            <a:ext cx="3566160" cy="237744"/>
-          </a:xfrm>
-          <a:prstGeom prst="rect">
-            <a:avLst/>
-          </a:prstGeom>
-          <a:noFill/>
-        </p:spPr>
-        <p:txBody>
-          <a:bodyPr wrap="square" lIns="0" tIns="0" rIns="0" bIns="0" anchor="t">
-            <a:spAutoFit/>
-          </a:bodyPr>
-          <a:lstStyle/>
-          <a:p>
-            <a:pPr algn="r">
-              <a:spcAft>
-                <a:spcPts val="400"/>
-              </a:spcAft>
-            </a:pPr>
-            <a:r>
-              <a:rPr sz="900" b="0">
-                <a:solidFill>
-                  <a:srgbClr val="8C8C8C"/>
-                </a:solidFill>
-                <a:latin typeface="游ゴシック"/>
-              </a:rPr>
-              <a:t>㈱タカハシ包装センター　社外秘　P10</a:t>
-            </a:r>
-          </a:p>
-        </p:txBody>
-      </p:sp>
-      <p:sp>
-        <p:nvSpPr>
-          <p:cNvPr id="10" name="TextBox 9"/>
-          <p:cNvSpPr txBox="1"/>
-          <p:nvPr/>
-        </p:nvSpPr>
-        <p:spPr>
-          <a:xfrm>
-            <a:off x="411480" y="6473952"/>
-            <a:ext cx="7863840" cy="237744"/>
-          </a:xfrm>
-          <a:prstGeom prst="rect">
-            <a:avLst/>
-          </a:prstGeom>
-          <a:noFill/>
-        </p:spPr>
-        <p:txBody>
-          <a:bodyPr wrap="square" lIns="0" tIns="0" rIns="0" bIns="0">
-            <a:spAutoFit/>
-          </a:bodyPr>
-          <a:lstStyle/>
-          <a:p>
-            <a:pPr algn="l"/>
-            <a:r>
-              <a:rPr sz="850" b="0">
-                <a:solidFill>
-                  <a:srgbClr val="8C8C8C"/>
-                </a:solidFill>
-                <a:latin typeface="游ゴシック"/>
-              </a:rPr>
-              <a:t>出所：2508・2608タカハシ包装売上全明細（機械類を除く）。突合対象外には単価が前年比0.25〜4.0倍の範囲外の品目（前年0.6・当年0.2百万円）を含む</a:t>
-            </a:r>
-          </a:p>
-        </p:txBody>
-      </p:sp>
-      <p:pic>
-        <p:nvPicPr>
-          <p:cNvPr id="11" name="Picture 10" descr="image.jpg"/>
-          <p:cNvPicPr>
-            <a:picLocks noChangeAspect="1"/>
-          </p:cNvPicPr>
-          <p:nvPr/>
-        </p:nvPicPr>
-        <p:blipFill>
-          <a:blip r:embed="rId2"/>
-          <a:stretch>
-            <a:fillRect/>
-          </a:stretch>
-        </p:blipFill>
-        <p:spPr>
-          <a:xfrm>
-            <a:off x="11259007" y="137160"/>
-            <a:ext cx="603504" cy="603504"/>
-          </a:xfrm>
-          <a:prstGeom prst="rect">
-            <a:avLst/>
-          </a:prstGeom>
-        </p:spPr>
-      </p:pic>
-      <p:graphicFrame>
-        <p:nvGraphicFramePr>
-          <p:cNvPr id="12" name="Chart 11"/>
-          <p:cNvGraphicFramePr>
-            <a:graphicFrameLocks noGrp="1"/>
-          </p:cNvGraphicFramePr>
-          <p:nvPr/>
-        </p:nvGraphicFramePr>
-        <p:xfrm>
-          <a:off x="411480" y="1143000"/>
-          <a:ext cx="6949440" cy="5120640"/>
-        </p:xfrm>
-        <a:graphic>
-          <a:graphicData uri="http://schemas.openxmlformats.org/drawingml/2006/chart">
-            <c:chart xmlns:c="http://schemas.openxmlformats.org/drawingml/2006/chart" r:id="rId3"/>
-          </a:graphicData>
-        </a:graphic>
-      </p:graphicFrame>
-      <p:sp>
-        <p:nvSpPr>
-          <p:cNvPr id="13" name="Rectangle 12"/>
-          <p:cNvSpPr/>
-          <p:nvPr/>
-        </p:nvSpPr>
-        <p:spPr>
-          <a:xfrm>
-            <a:off x="7589520" y="1143000"/>
-            <a:ext cx="4160520" cy="1600200"/>
-          </a:xfrm>
-          <a:prstGeom prst="rect">
-            <a:avLst/>
-          </a:prstGeom>
-          <a:solidFill>
-            <a:srgbClr val="F7F9FC"/>
-          </a:solidFill>
-          <a:ln>
-            <a:noFill/>
-          </a:ln>
-          <a:effectLst/>
-        </p:spPr>
-        <p:style>
-          <a:lnRef idx="1">
-            <a:schemeClr val="accent1"/>
-          </a:lnRef>
-          <a:fillRef idx="3">
-            <a:schemeClr val="accent1"/>
-          </a:fillRef>
-          <a:effectRef idx="2">
-            <a:schemeClr val="accent1"/>
-          </a:effectRef>
-          <a:fontRef idx="minor">
-            <a:schemeClr val="lt1"/>
-          </a:fontRef>
-        </p:style>
-        <p:txBody>
-          <a:bodyPr rtlCol="0" anchor="ctr"/>
-          <a:lstStyle/>
-          <a:p>
-            <a:pPr algn="ctr"/>
-          </a:p>
-        </p:txBody>
-      </p:sp>
-      <p:sp>
-        <p:nvSpPr>
-          <p:cNvPr id="14" name="TextBox 13"/>
-          <p:cNvSpPr txBox="1"/>
-          <p:nvPr/>
-        </p:nvSpPr>
-        <p:spPr>
-          <a:xfrm>
-            <a:off x="7726680" y="1216152"/>
-            <a:ext cx="3886200" cy="1453896"/>
-          </a:xfrm>
-          <a:prstGeom prst="rect">
-            <a:avLst/>
-          </a:prstGeom>
-          <a:noFill/>
-        </p:spPr>
-        <p:txBody>
-          <a:bodyPr wrap="square" lIns="0" rIns="0">
-            <a:spAutoFit/>
-          </a:bodyPr>
-          <a:lstStyle/>
-          <a:p>
-            <a:r>
-              <a:rPr sz="1200" b="1">
-                <a:solidFill>
-                  <a:srgbClr val="1F3864"/>
-                </a:solidFill>
-                <a:latin typeface="游ゴシック"/>
-              </a:rPr>
-              <a:t>「突合」＝同一商品コードどうしの比較</a:t>
-            </a:r>
-          </a:p>
-          <a:p>
-            <a:pPr>
-              <a:spcBef>
-                <a:spcPts val="400"/>
-              </a:spcBef>
-            </a:pPr>
-            <a:r>
-              <a:rPr sz="1000" b="0">
-                <a:solidFill>
-                  <a:srgbClr val="404040"/>
-                </a:solidFill>
-                <a:latin typeface="游ゴシック"/>
-              </a:rPr>
-              <a:t>単価寄与＋19.6％は、同じ商品が値上げされた効果。材質・色数などの仕様変更で商品コードが変わった品目（スペックダウンを含む）は突合できず、単価・数量には入らない。</a:t>
-            </a:r>
-          </a:p>
-        </p:txBody>
-      </p:sp>
-      <p:sp>
-        <p:nvSpPr>
-          <p:cNvPr id="15" name="Rectangle 14"/>
-          <p:cNvSpPr/>
-          <p:nvPr/>
-        </p:nvSpPr>
-        <p:spPr>
-          <a:xfrm>
-            <a:off x="7589520" y="2834640"/>
-            <a:ext cx="4160520" cy="1600200"/>
-          </a:xfrm>
-          <a:prstGeom prst="rect">
-            <a:avLst/>
-          </a:prstGeom>
-          <a:solidFill>
-            <a:srgbClr val="F7F9FC"/>
-          </a:solidFill>
-          <a:ln>
-            <a:noFill/>
-          </a:ln>
-          <a:effectLst/>
-        </p:spPr>
-        <p:style>
-          <a:lnRef idx="1">
-            <a:schemeClr val="accent1"/>
-          </a:lnRef>
-          <a:fillRef idx="3">
-            <a:schemeClr val="accent1"/>
-          </a:fillRef>
-          <a:effectRef idx="2">
-            <a:schemeClr val="accent1"/>
-          </a:effectRef>
-          <a:fontRef idx="minor">
-            <a:schemeClr val="lt1"/>
-          </a:fontRef>
-        </p:style>
-        <p:txBody>
-          <a:bodyPr rtlCol="0" anchor="ctr"/>
-          <a:lstStyle/>
-          <a:p>
-            <a:pPr algn="ctr"/>
-          </a:p>
-        </p:txBody>
-      </p:sp>
-      <p:sp>
-        <p:nvSpPr>
-          <p:cNvPr id="16" name="TextBox 15"/>
-          <p:cNvSpPr txBox="1"/>
-          <p:nvPr/>
-        </p:nvSpPr>
-        <p:spPr>
-          <a:xfrm>
-            <a:off x="7726680" y="2907792"/>
-            <a:ext cx="3886200" cy="1453896"/>
-          </a:xfrm>
-          <a:prstGeom prst="rect">
-            <a:avLst/>
-          </a:prstGeom>
-          <a:noFill/>
-        </p:spPr>
-        <p:txBody>
-          <a:bodyPr wrap="square" lIns="0" rIns="0">
-            <a:spAutoFit/>
-          </a:bodyPr>
-          <a:lstStyle/>
-          <a:p>
-            <a:r>
-              <a:rPr sz="1200" b="1">
-                <a:solidFill>
-                  <a:srgbClr val="C00000"/>
-                </a:solidFill>
-                <a:latin typeface="游ゴシック"/>
-              </a:rPr>
-              <a:t>品目入替は差し引き▲9.3百万円</a:t>
-            </a:r>
-          </a:p>
-          <a:p>
-            <a:pPr>
-              <a:spcBef>
-                <a:spcPts val="400"/>
-              </a:spcBef>
-            </a:pPr>
-            <a:r>
-              <a:rPr sz="1000" b="0">
-                <a:solidFill>
-                  <a:srgbClr val="404040"/>
-                </a:solidFill>
-                <a:latin typeface="游ゴシック"/>
-              </a:rPr>
-              <a:t>前年のみの品目79.9百万円が消え、当年のみの品目70.7百万円が入った。スペックダウン（単価引下げ）や安価品への切替の影響はここに含まれ、単価効果を打ち消す方向に働いている。</a:t>
-            </a:r>
-          </a:p>
-        </p:txBody>
-      </p:sp>
-      <p:sp>
-        <p:nvSpPr>
-          <p:cNvPr id="17" name="Rectangle 16"/>
-          <p:cNvSpPr/>
-          <p:nvPr/>
-        </p:nvSpPr>
-        <p:spPr>
-          <a:xfrm>
-            <a:off x="7589520" y="4526280"/>
-            <a:ext cx="4160520" cy="1737360"/>
-          </a:xfrm>
-          <a:prstGeom prst="rect">
-            <a:avLst/>
-          </a:prstGeom>
-          <a:solidFill>
-            <a:srgbClr val="F7F9FC"/>
-          </a:solidFill>
-          <a:ln>
-            <a:noFill/>
-          </a:ln>
-          <a:effectLst/>
-        </p:spPr>
-        <p:style>
-          <a:lnRef idx="1">
-            <a:schemeClr val="accent1"/>
-          </a:lnRef>
-          <a:fillRef idx="3">
-            <a:schemeClr val="accent1"/>
-          </a:fillRef>
-          <a:effectRef idx="2">
-            <a:schemeClr val="accent1"/>
-          </a:effectRef>
-          <a:fontRef idx="minor">
-            <a:schemeClr val="lt1"/>
-          </a:fontRef>
-        </p:style>
-        <p:txBody>
-          <a:bodyPr rtlCol="0" anchor="ctr"/>
-          <a:lstStyle/>
-          <a:p>
-            <a:pPr algn="ctr"/>
-          </a:p>
-        </p:txBody>
-      </p:sp>
-      <p:sp>
-        <p:nvSpPr>
-          <p:cNvPr id="18" name="TextBox 17"/>
-          <p:cNvSpPr txBox="1"/>
-          <p:nvPr/>
-        </p:nvSpPr>
-        <p:spPr>
-          <a:xfrm>
-            <a:off x="7726680" y="4599432"/>
-            <a:ext cx="3886200" cy="1591056"/>
-          </a:xfrm>
-          <a:prstGeom prst="rect">
-            <a:avLst/>
-          </a:prstGeom>
-          <a:noFill/>
-        </p:spPr>
-        <p:txBody>
-          <a:bodyPr wrap="square" lIns="0" rIns="0">
-            <a:spAutoFit/>
-          </a:bodyPr>
-          <a:lstStyle/>
-          <a:p>
-            <a:r>
-              <a:rPr sz="1200" b="1">
-                <a:solidFill>
-                  <a:srgbClr val="B8860B"/>
-                </a:solidFill>
-                <a:latin typeface="游ゴシック"/>
-              </a:rPr>
-              <a:t>計画に使うのは「全体」の伸び率</a:t>
-            </a:r>
-          </a:p>
-          <a:p>
-            <a:pPr>
-              <a:spcBef>
-                <a:spcPts val="400"/>
-              </a:spcBef>
-            </a:pPr>
-            <a:r>
-              <a:rPr sz="1000" b="0">
-                <a:solidFill>
-                  <a:srgbClr val="404040"/>
-                </a:solidFill>
-                <a:latin typeface="游ゴシック"/>
-              </a:rPr>
-              <a:t>突合ベースの＋17.0％をそのまま伸び率にすると過大。包装資材全体では＋7.5％で、これが計画の出発点。単価寄与は「値上げがどこまで進んだか」を測る指標として使う。</a:t>
-            </a:r>
-          </a:p>
-        </p:txBody>
-      </p:sp>
-    </p:spTree>
-  </p:cSld>
-  <p:clrMapOvr>
-    <a:masterClrMapping/>
-  </p:clrMapOvr>
-</p:sld>
-</file>
-
 <file path=ppt/slides/slide14.xml><?xml version="1.0" encoding="utf-8"?>
 <p:sld xmlns:a="http://schemas.openxmlformats.org/drawingml/2006/main" xmlns:p="http://schemas.openxmlformats.org/presentationml/2006/main" xmlns:r="http://schemas.openxmlformats.org/officeDocument/2006/relationships">
   <p:cSld>
@@ -18501,7 +18502,7 @@
                 </a:solidFill>
                 <a:latin typeface="游ゴシック"/>
               </a:rPr>
-              <a:t>㈱タカハシ包装センター　社外秘　P14</a:t>
+              <a:t>㈱タカハシ包装センター　社外秘　P15</a:t>
             </a:r>
           </a:p>
         </p:txBody>
@@ -20319,7 +20320,7 @@
                 </a:solidFill>
                 <a:latin typeface="游ゴシック"/>
               </a:rPr>
-              <a:t>㈱タカハシ包装センター　社外秘　P15</a:t>
+              <a:t>㈱タカハシ包装センター　社外秘　P16</a:t>
             </a:r>
           </a:p>
         </p:txBody>
@@ -21680,6 +21681,3158 @@
                 <a:latin typeface="游ゴシック"/>
               </a:rPr>
               <a:t>※ 機械の第52期計画は6営業所計179,500千円で、第51期見込220,200千円から▲18.5％。境港は前年の大型案件の反動で減少計画だが、メンテナンス要員がいる営業所は保守・更新提案の分を上乗せして「明示的に上げる」対象とする。</a:t>
+            </a:r>
+          </a:p>
+        </p:txBody>
+      </p:sp>
+    </p:spTree>
+  </p:cSld>
+  <p:clrMapOvr>
+    <a:masterClrMapping/>
+  </p:clrMapOvr>
+</p:sld>
+</file>
+
+<file path=ppt/slides/slide16.xml><?xml version="1.0" encoding="utf-8"?>
+<p:sld xmlns:a="http://schemas.openxmlformats.org/drawingml/2006/main" xmlns:p="http://schemas.openxmlformats.org/presentationml/2006/main" xmlns:r="http://schemas.openxmlformats.org/officeDocument/2006/relationships">
+  <p:cSld>
+    <p:spTree>
+      <p:nvGrpSpPr>
+        <p:cNvPr id="1" name=""/>
+        <p:cNvGrpSpPr/>
+        <p:nvPr/>
+      </p:nvGrpSpPr>
+      <p:grpSpPr/>
+      <p:sp>
+        <p:nvSpPr>
+          <p:cNvPr id="2" name="Rectangle 1"/>
+          <p:cNvSpPr/>
+          <p:nvPr/>
+        </p:nvSpPr>
+        <p:spPr>
+          <a:xfrm>
+            <a:off x="0" y="0"/>
+            <a:ext cx="64008" cy="6858000"/>
+          </a:xfrm>
+          <a:prstGeom prst="rect">
+            <a:avLst/>
+          </a:prstGeom>
+          <a:solidFill>
+            <a:srgbClr val="B8860B"/>
+          </a:solidFill>
+          <a:ln>
+            <a:noFill/>
+          </a:ln>
+          <a:effectLst/>
+        </p:spPr>
+        <p:style>
+          <a:lnRef idx="1">
+            <a:schemeClr val="accent1"/>
+          </a:lnRef>
+          <a:fillRef idx="3">
+            <a:schemeClr val="accent1"/>
+          </a:fillRef>
+          <a:effectRef idx="2">
+            <a:schemeClr val="accent1"/>
+          </a:effectRef>
+          <a:fontRef idx="minor">
+            <a:schemeClr val="lt1"/>
+          </a:fontRef>
+        </p:style>
+        <p:txBody>
+          <a:bodyPr wrap="square" rtlCol="0" anchor="ctr"/>
+          <a:lstStyle/>
+          <a:p>
+            <a:pPr algn="ctr"/>
+            <a:endParaRPr/>
+          </a:p>
+        </p:txBody>
+      </p:sp>
+      <p:sp>
+        <p:nvSpPr>
+          <p:cNvPr id="3" name="Rectangle 2"/>
+          <p:cNvSpPr/>
+          <p:nvPr/>
+        </p:nvSpPr>
+        <p:spPr>
+          <a:xfrm>
+            <a:off x="0" y="0"/>
+            <a:ext cx="12191695" cy="877824"/>
+          </a:xfrm>
+          <a:prstGeom prst="rect">
+            <a:avLst/>
+          </a:prstGeom>
+          <a:solidFill>
+            <a:srgbClr val="1F3864"/>
+          </a:solidFill>
+          <a:ln>
+            <a:noFill/>
+          </a:ln>
+          <a:effectLst/>
+        </p:spPr>
+        <p:style>
+          <a:lnRef idx="1">
+            <a:schemeClr val="accent1"/>
+          </a:lnRef>
+          <a:fillRef idx="3">
+            <a:schemeClr val="accent1"/>
+          </a:fillRef>
+          <a:effectRef idx="2">
+            <a:schemeClr val="accent1"/>
+          </a:effectRef>
+          <a:fontRef idx="minor">
+            <a:schemeClr val="lt1"/>
+          </a:fontRef>
+        </p:style>
+        <p:txBody>
+          <a:bodyPr wrap="square" rtlCol="0" anchor="ctr"/>
+          <a:lstStyle/>
+          <a:p>
+            <a:pPr algn="ctr"/>
+            <a:endParaRPr/>
+          </a:p>
+        </p:txBody>
+      </p:sp>
+      <p:sp>
+        <p:nvSpPr>
+          <p:cNvPr id="4" name="TextBox 3"/>
+          <p:cNvSpPr txBox="1"/>
+          <p:nvPr/>
+        </p:nvSpPr>
+        <p:spPr>
+          <a:xfrm>
+            <a:off x="411480" y="109728"/>
+            <a:ext cx="2377440" cy="237744"/>
+          </a:xfrm>
+          <a:prstGeom prst="rect">
+            <a:avLst/>
+          </a:prstGeom>
+          <a:noFill/>
+        </p:spPr>
+        <p:txBody>
+          <a:bodyPr wrap="square" lIns="0" tIns="0" rIns="0" bIns="0" anchor="t">
+            <a:spAutoFit/>
+          </a:bodyPr>
+          <a:lstStyle/>
+          <a:p>
+            <a:pPr algn="l">
+              <a:spcAft>
+                <a:spcPts val="400"/>
+              </a:spcAft>
+            </a:pPr>
+            <a:r>
+              <a:rPr sz="950" b="1">
+                <a:solidFill>
+                  <a:srgbClr val="B8860B"/>
+                </a:solidFill>
+                <a:latin typeface="游ゴシック"/>
+              </a:rPr>
+              <a:t>第3章　当社の実績</a:t>
+            </a:r>
+          </a:p>
+        </p:txBody>
+      </p:sp>
+      <p:sp>
+        <p:nvSpPr>
+          <p:cNvPr id="5" name="TextBox 4"/>
+          <p:cNvSpPr txBox="1"/>
+          <p:nvPr/>
+        </p:nvSpPr>
+        <p:spPr>
+          <a:xfrm>
+            <a:off x="411480" y="310896"/>
+            <a:ext cx="10195560" cy="365760"/>
+          </a:xfrm>
+          <a:prstGeom prst="rect">
+            <a:avLst/>
+          </a:prstGeom>
+          <a:noFill/>
+        </p:spPr>
+        <p:txBody>
+          <a:bodyPr wrap="square" lIns="0" tIns="0" rIns="0" bIns="0" anchor="t">
+            <a:spAutoFit/>
+          </a:bodyPr>
+          <a:lstStyle/>
+          <a:p>
+            <a:pPr algn="l">
+              <a:spcAft>
+                <a:spcPts val="400"/>
+              </a:spcAft>
+            </a:pPr>
+            <a:r>
+              <a:rPr sz="2300" b="1">
+                <a:solidFill>
+                  <a:srgbClr val="FFFFFF"/>
+                </a:solidFill>
+                <a:latin typeface="游ゴシック"/>
+              </a:rPr>
+              <a:t>分類別の平均単価で見たスペック変更の影響【機械類を除く】</a:t>
+            </a:r>
+          </a:p>
+        </p:txBody>
+      </p:sp>
+      <p:sp>
+        <p:nvSpPr>
+          <p:cNvPr id="6" name="TextBox 5"/>
+          <p:cNvSpPr txBox="1"/>
+          <p:nvPr/>
+        </p:nvSpPr>
+        <p:spPr>
+          <a:xfrm>
+            <a:off x="429768" y="658368"/>
+            <a:ext cx="10195560" cy="219456"/>
+          </a:xfrm>
+          <a:prstGeom prst="rect">
+            <a:avLst/>
+          </a:prstGeom>
+          <a:noFill/>
+        </p:spPr>
+        <p:txBody>
+          <a:bodyPr wrap="square" lIns="0" tIns="0" rIns="0" bIns="0" anchor="t">
+            <a:spAutoFit/>
+          </a:bodyPr>
+          <a:lstStyle/>
+          <a:p>
+            <a:pPr algn="l">
+              <a:spcAft>
+                <a:spcPts val="400"/>
+              </a:spcAft>
+            </a:pPr>
+            <a:r>
+              <a:rPr sz="1050" b="0">
+                <a:solidFill>
+                  <a:srgbClr val="D6E4F0"/>
+                </a:solidFill>
+                <a:latin typeface="游ゴシック"/>
+              </a:rPr>
+              <a:t>分類ごとの平均単価（売上金額÷売上数量）は突合できない品目も含むため、仕様変更で商品コードが変わった分も反映される。前年売上ウエイトで加重。8月の前年同月比</a:t>
+            </a:r>
+          </a:p>
+        </p:txBody>
+      </p:sp>
+      <p:sp>
+        <p:nvSpPr>
+          <p:cNvPr id="8" name="TextBox 7"/>
+          <p:cNvSpPr txBox="1"/>
+          <p:nvPr/>
+        </p:nvSpPr>
+        <p:spPr>
+          <a:xfrm>
+            <a:off x="8259775" y="6473952"/>
+            <a:ext cx="3566160" cy="237744"/>
+          </a:xfrm>
+          <a:prstGeom prst="rect">
+            <a:avLst/>
+          </a:prstGeom>
+          <a:noFill/>
+        </p:spPr>
+        <p:txBody>
+          <a:bodyPr wrap="square" lIns="0" tIns="0" rIns="0" bIns="0" anchor="t">
+            <a:spAutoFit/>
+          </a:bodyPr>
+          <a:lstStyle/>
+          <a:p>
+            <a:pPr algn="r">
+              <a:spcAft>
+                <a:spcPts val="400"/>
+              </a:spcAft>
+            </a:pPr>
+            <a:r>
+              <a:rPr sz="900" b="0">
+                <a:solidFill>
+                  <a:srgbClr val="8C8C8C"/>
+                </a:solidFill>
+                <a:latin typeface="游ゴシック"/>
+              </a:rPr>
+              <a:t>㈱タカハシ包装センター　社外秘　P11</a:t>
+            </a:r>
+          </a:p>
+        </p:txBody>
+      </p:sp>
+      <p:sp>
+        <p:nvSpPr>
+          <p:cNvPr id="10" name="TextBox 9"/>
+          <p:cNvSpPr txBox="1"/>
+          <p:nvPr/>
+        </p:nvSpPr>
+        <p:spPr>
+          <a:xfrm>
+            <a:off x="411480" y="6473952"/>
+            <a:ext cx="7863840" cy="237744"/>
+          </a:xfrm>
+          <a:prstGeom prst="rect">
+            <a:avLst/>
+          </a:prstGeom>
+          <a:noFill/>
+        </p:spPr>
+        <p:txBody>
+          <a:bodyPr wrap="square" lIns="0" tIns="0" rIns="0" bIns="0">
+            <a:spAutoFit/>
+          </a:bodyPr>
+          <a:lstStyle/>
+          <a:p>
+            <a:pPr algn="l"/>
+            <a:r>
+              <a:rPr sz="850" b="0">
+                <a:solidFill>
+                  <a:srgbClr val="8C8C8C"/>
+                </a:solidFill>
+                <a:latin typeface="游ゴシック"/>
+              </a:rPr>
+              <a:t>出所：2508・2608タカハシ包装売上全明細。分類は旧43分類（分類コード1）。「散らばり」は分類内の販売単価の上位10％÷下位10％。散らばり10倍以内を「単位がそろう」と判定</a:t>
+            </a:r>
+          </a:p>
+        </p:txBody>
+      </p:sp>
+      <p:pic>
+        <p:nvPicPr>
+          <p:cNvPr id="11" name="Picture 10" descr="image.jpg"/>
+          <p:cNvPicPr>
+            <a:picLocks noChangeAspect="1"/>
+          </p:cNvPicPr>
+          <p:nvPr/>
+        </p:nvPicPr>
+        <p:blipFill>
+          <a:blip r:embed="rId2"/>
+          <a:stretch>
+            <a:fillRect/>
+          </a:stretch>
+        </p:blipFill>
+        <p:spPr>
+          <a:xfrm>
+            <a:off x="11259007" y="137160"/>
+            <a:ext cx="603504" cy="603504"/>
+          </a:xfrm>
+          <a:prstGeom prst="rect">
+            <a:avLst/>
+          </a:prstGeom>
+        </p:spPr>
+      </p:pic>
+      <p:sp>
+        <p:nvSpPr>
+          <p:cNvPr id="12" name="TextBox 11"/>
+          <p:cNvSpPr txBox="1"/>
+          <p:nvPr/>
+        </p:nvSpPr>
+        <p:spPr>
+          <a:xfrm>
+            <a:off x="411480" y="1097280"/>
+            <a:ext cx="5486400" cy="274320"/>
+          </a:xfrm>
+          <a:prstGeom prst="rect">
+            <a:avLst/>
+          </a:prstGeom>
+          <a:noFill/>
+        </p:spPr>
+        <p:txBody>
+          <a:bodyPr wrap="none" lIns="0">
+            <a:spAutoFit/>
+          </a:bodyPr>
+          <a:lstStyle/>
+          <a:p>
+            <a:r>
+              <a:rPr sz="1100" b="1">
+                <a:solidFill>
+                  <a:srgbClr val="1F3864"/>
+                </a:solidFill>
+                <a:latin typeface="游ゴシック"/>
+              </a:rPr>
+              <a:t>商品群別 ―― 分類別平均単価指数 と 突合単価効果 の比較</a:t>
+            </a:r>
+          </a:p>
+        </p:txBody>
+      </p:sp>
+      <p:graphicFrame>
+        <p:nvGraphicFramePr>
+          <p:cNvPr id="13" name="Table 12"/>
+          <p:cNvGraphicFramePr>
+            <a:graphicFrameLocks noGrp="1"/>
+          </p:cNvGraphicFramePr>
+          <p:nvPr/>
+        </p:nvGraphicFramePr>
+        <p:xfrm>
+          <a:off x="411480" y="1389888"/>
+          <a:ext cx="5577839" cy="2240280"/>
+        </p:xfrm>
+        <a:graphic>
+          <a:graphicData uri="http://schemas.openxmlformats.org/drawingml/2006/table">
+            <a:tbl>
+              <a:tblPr firstRow="0" bandRow="0"/>
+              <a:tblGrid>
+                <a:gridCol w="1859280"/>
+                <a:gridCol w="845127"/>
+                <a:gridCol w="1014152"/>
+                <a:gridCol w="929640"/>
+                <a:gridCol w="929640"/>
+              </a:tblGrid>
+              <a:tr h="384048">
+                <a:tc>
+                  <a:txBody>
+                    <a:bodyPr/>
+                    <a:lstStyle/>
+                    <a:p>
+                      <a:pPr algn="ctr"/>
+                      <a:r>
+                        <a:rPr sz="800" b="1">
+                          <a:solidFill>
+                            <a:srgbClr val="FFFFFF"/>
+                          </a:solidFill>
+                          <a:latin typeface="游ゴシック"/>
+                        </a:rPr>
+                        <a:t>商品群</a:t>
+                      </a:r>
+                    </a:p>
+                  </a:txBody>
+                  <a:tcPr marL="45720" marR="45720" marT="18288" marB="18288" anchor="ctr">
+                    <a:solidFill>
+                      <a:srgbClr val="1F3864"/>
+                    </a:solidFill>
+                  </a:tcPr>
+                </a:tc>
+                <a:tc>
+                  <a:txBody>
+                    <a:bodyPr/>
+                    <a:lstStyle/>
+                    <a:p>
+                      <a:pPr algn="ctr"/>
+                      <a:r>
+                        <a:rPr sz="800" b="1">
+                          <a:solidFill>
+                            <a:srgbClr val="FFFFFF"/>
+                          </a:solidFill>
+                          <a:latin typeface="游ゴシック"/>
+                        </a:rPr>
+                        <a:t>売上増減</a:t>
+                      </a:r>
+                    </a:p>
+                  </a:txBody>
+                  <a:tcPr marL="45720" marR="45720" marT="18288" marB="18288" anchor="ctr">
+                    <a:solidFill>
+                      <a:srgbClr val="1F3864"/>
+                    </a:solidFill>
+                  </a:tcPr>
+                </a:tc>
+                <a:tc>
+                  <a:txBody>
+                    <a:bodyPr/>
+                    <a:lstStyle/>
+                    <a:p>
+                      <a:pPr algn="ctr"/>
+                      <a:r>
+                        <a:rPr sz="800" b="1">
+                          <a:solidFill>
+                            <a:srgbClr val="FFFFFF"/>
+                          </a:solidFill>
+                          <a:latin typeface="游ゴシック"/>
+                        </a:rPr>
+                        <a:t>分類別
+平均単価指数</a:t>
+                      </a:r>
+                    </a:p>
+                  </a:txBody>
+                  <a:tcPr marL="45720" marR="45720" marT="18288" marB="18288" anchor="ctr">
+                    <a:solidFill>
+                      <a:srgbClr val="1F3864"/>
+                    </a:solidFill>
+                  </a:tcPr>
+                </a:tc>
+                <a:tc>
+                  <a:txBody>
+                    <a:bodyPr/>
+                    <a:lstStyle/>
+                    <a:p>
+                      <a:pPr algn="ctr"/>
+                      <a:r>
+                        <a:rPr sz="800" b="1">
+                          <a:solidFill>
+                            <a:srgbClr val="FFFFFF"/>
+                          </a:solidFill>
+                          <a:latin typeface="游ゴシック"/>
+                        </a:rPr>
+                        <a:t>突合
+単価効果</a:t>
+                      </a:r>
+                    </a:p>
+                  </a:txBody>
+                  <a:tcPr marL="45720" marR="45720" marT="18288" marB="18288" anchor="ctr">
+                    <a:solidFill>
+                      <a:srgbClr val="1F3864"/>
+                    </a:solidFill>
+                  </a:tcPr>
+                </a:tc>
+                <a:tc>
+                  <a:txBody>
+                    <a:bodyPr/>
+                    <a:lstStyle/>
+                    <a:p>
+                      <a:pPr algn="ctr"/>
+                      <a:r>
+                        <a:rPr sz="800" b="1">
+                          <a:solidFill>
+                            <a:srgbClr val="FFFFFF"/>
+                          </a:solidFill>
+                          <a:latin typeface="游ゴシック"/>
+                        </a:rPr>
+                        <a:t>差（スペック・
+ミックス）</a:t>
+                      </a:r>
+                    </a:p>
+                  </a:txBody>
+                  <a:tcPr marL="45720" marR="45720" marT="18288" marB="18288" anchor="ctr">
+                    <a:solidFill>
+                      <a:srgbClr val="1F3864"/>
+                    </a:solidFill>
+                  </a:tcPr>
+                </a:tc>
+              </a:tr>
+              <a:tr h="265176">
+                <a:tc>
+                  <a:txBody>
+                    <a:bodyPr/>
+                    <a:lstStyle/>
+                    <a:p>
+                      <a:pPr algn="l"/>
+                      <a:r>
+                        <a:rPr sz="900" b="0">
+                          <a:solidFill>
+                            <a:srgbClr val="404040"/>
+                          </a:solidFill>
+                          <a:latin typeface="游ゴシック"/>
+                        </a:rPr>
+                        <a:t>食品容器</a:t>
+                      </a:r>
+                    </a:p>
+                  </a:txBody>
+                  <a:tcPr marL="45720" marR="45720" marT="18288" marB="18288" anchor="ctr">
+                    <a:noFill/>
+                  </a:tcPr>
+                </a:tc>
+                <a:tc>
+                  <a:txBody>
+                    <a:bodyPr/>
+                    <a:lstStyle/>
+                    <a:p>
+                      <a:pPr algn="r"/>
+                      <a:r>
+                        <a:rPr sz="900" b="0">
+                          <a:solidFill>
+                            <a:srgbClr val="404040"/>
+                          </a:solidFill>
+                          <a:latin typeface="游ゴシック"/>
+                        </a:rPr>
+                        <a:t>＋10.7％</a:t>
+                      </a:r>
+                    </a:p>
+                  </a:txBody>
+                  <a:tcPr marL="45720" marR="45720" marT="18288" marB="18288" anchor="ctr">
+                    <a:noFill/>
+                  </a:tcPr>
+                </a:tc>
+                <a:tc>
+                  <a:txBody>
+                    <a:bodyPr/>
+                    <a:lstStyle/>
+                    <a:p>
+                      <a:pPr algn="r"/>
+                      <a:r>
+                        <a:rPr sz="900" b="1">
+                          <a:solidFill>
+                            <a:srgbClr val="B8860B"/>
+                          </a:solidFill>
+                          <a:latin typeface="游ゴシック"/>
+                        </a:rPr>
+                        <a:t>＋19.4％</a:t>
+                      </a:r>
+                    </a:p>
+                  </a:txBody>
+                  <a:tcPr marL="45720" marR="45720" marT="18288" marB="18288" anchor="ctr">
+                    <a:noFill/>
+                  </a:tcPr>
+                </a:tc>
+                <a:tc>
+                  <a:txBody>
+                    <a:bodyPr/>
+                    <a:lstStyle/>
+                    <a:p>
+                      <a:pPr algn="r"/>
+                      <a:r>
+                        <a:rPr sz="900" b="0">
+                          <a:solidFill>
+                            <a:srgbClr val="404040"/>
+                          </a:solidFill>
+                          <a:latin typeface="游ゴシック"/>
+                        </a:rPr>
+                        <a:t>＋23.9％</a:t>
+                      </a:r>
+                    </a:p>
+                  </a:txBody>
+                  <a:tcPr marL="45720" marR="45720" marT="18288" marB="18288" anchor="ctr">
+                    <a:noFill/>
+                  </a:tcPr>
+                </a:tc>
+                <a:tc>
+                  <a:txBody>
+                    <a:bodyPr/>
+                    <a:lstStyle/>
+                    <a:p>
+                      <a:pPr algn="r"/>
+                      <a:r>
+                        <a:rPr sz="900" b="1">
+                          <a:solidFill>
+                            <a:srgbClr val="C00000"/>
+                          </a:solidFill>
+                          <a:latin typeface="游ゴシック"/>
+                        </a:rPr>
+                        <a:t>▲4.5pt</a:t>
+                      </a:r>
+                    </a:p>
+                  </a:txBody>
+                  <a:tcPr marL="45720" marR="45720" marT="18288" marB="18288" anchor="ctr">
+                    <a:noFill/>
+                  </a:tcPr>
+                </a:tc>
+              </a:tr>
+              <a:tr h="265176">
+                <a:tc>
+                  <a:txBody>
+                    <a:bodyPr/>
+                    <a:lstStyle/>
+                    <a:p>
+                      <a:pPr algn="l"/>
+                      <a:r>
+                        <a:rPr sz="900" b="0">
+                          <a:solidFill>
+                            <a:srgbClr val="404040"/>
+                          </a:solidFill>
+                          <a:latin typeface="游ゴシック"/>
+                        </a:rPr>
+                        <a:t>フィルム・袋・ラミネート</a:t>
+                      </a:r>
+                    </a:p>
+                  </a:txBody>
+                  <a:tcPr marL="45720" marR="45720" marT="18288" marB="18288" anchor="ctr">
+                    <a:solidFill>
+                      <a:srgbClr val="F2F2F2"/>
+                    </a:solidFill>
+                  </a:tcPr>
+                </a:tc>
+                <a:tc>
+                  <a:txBody>
+                    <a:bodyPr/>
+                    <a:lstStyle/>
+                    <a:p>
+                      <a:pPr algn="r"/>
+                      <a:r>
+                        <a:rPr sz="900" b="0">
+                          <a:solidFill>
+                            <a:srgbClr val="404040"/>
+                          </a:solidFill>
+                          <a:latin typeface="游ゴシック"/>
+                        </a:rPr>
+                        <a:t>＋9.3％</a:t>
+                      </a:r>
+                    </a:p>
+                  </a:txBody>
+                  <a:tcPr marL="45720" marR="45720" marT="18288" marB="18288" anchor="ctr">
+                    <a:solidFill>
+                      <a:srgbClr val="F2F2F2"/>
+                    </a:solidFill>
+                  </a:tcPr>
+                </a:tc>
+                <a:tc>
+                  <a:txBody>
+                    <a:bodyPr/>
+                    <a:lstStyle/>
+                    <a:p>
+                      <a:pPr algn="r"/>
+                      <a:r>
+                        <a:rPr sz="900" b="1">
+                          <a:solidFill>
+                            <a:srgbClr val="B8860B"/>
+                          </a:solidFill>
+                          <a:latin typeface="游ゴシック"/>
+                        </a:rPr>
+                        <a:t>＋25.1％</a:t>
+                      </a:r>
+                    </a:p>
+                  </a:txBody>
+                  <a:tcPr marL="45720" marR="45720" marT="18288" marB="18288" anchor="ctr">
+                    <a:solidFill>
+                      <a:srgbClr val="F2F2F2"/>
+                    </a:solidFill>
+                  </a:tcPr>
+                </a:tc>
+                <a:tc>
+                  <a:txBody>
+                    <a:bodyPr/>
+                    <a:lstStyle/>
+                    <a:p>
+                      <a:pPr algn="r"/>
+                      <a:r>
+                        <a:rPr sz="900" b="0">
+                          <a:solidFill>
+                            <a:srgbClr val="404040"/>
+                          </a:solidFill>
+                          <a:latin typeface="游ゴシック"/>
+                        </a:rPr>
+                        <a:t>＋25.9％</a:t>
+                      </a:r>
+                    </a:p>
+                  </a:txBody>
+                  <a:tcPr marL="45720" marR="45720" marT="18288" marB="18288" anchor="ctr">
+                    <a:solidFill>
+                      <a:srgbClr val="F2F2F2"/>
+                    </a:solidFill>
+                  </a:tcPr>
+                </a:tc>
+                <a:tc>
+                  <a:txBody>
+                    <a:bodyPr/>
+                    <a:lstStyle/>
+                    <a:p>
+                      <a:pPr algn="r"/>
+                      <a:r>
+                        <a:rPr sz="900" b="1">
+                          <a:solidFill>
+                            <a:srgbClr val="C00000"/>
+                          </a:solidFill>
+                          <a:latin typeface="游ゴシック"/>
+                        </a:rPr>
+                        <a:t>▲0.9pt</a:t>
+                      </a:r>
+                    </a:p>
+                  </a:txBody>
+                  <a:tcPr marL="45720" marR="45720" marT="18288" marB="18288" anchor="ctr">
+                    <a:solidFill>
+                      <a:srgbClr val="F2F2F2"/>
+                    </a:solidFill>
+                  </a:tcPr>
+                </a:tc>
+              </a:tr>
+              <a:tr h="265176">
+                <a:tc>
+                  <a:txBody>
+                    <a:bodyPr/>
+                    <a:lstStyle/>
+                    <a:p>
+                      <a:pPr algn="l"/>
+                      <a:r>
+                        <a:rPr sz="900" b="0">
+                          <a:solidFill>
+                            <a:srgbClr val="404040"/>
+                          </a:solidFill>
+                          <a:latin typeface="游ゴシック"/>
+                        </a:rPr>
+                        <a:t>紙箱・紙製品・ラベル・段ボール</a:t>
+                      </a:r>
+                    </a:p>
+                  </a:txBody>
+                  <a:tcPr marL="45720" marR="45720" marT="18288" marB="18288" anchor="ctr">
+                    <a:noFill/>
+                  </a:tcPr>
+                </a:tc>
+                <a:tc>
+                  <a:txBody>
+                    <a:bodyPr/>
+                    <a:lstStyle/>
+                    <a:p>
+                      <a:pPr algn="r"/>
+                      <a:r>
+                        <a:rPr sz="900" b="0">
+                          <a:solidFill>
+                            <a:srgbClr val="404040"/>
+                          </a:solidFill>
+                          <a:latin typeface="游ゴシック"/>
+                        </a:rPr>
+                        <a:t>＋4.0％</a:t>
+                      </a:r>
+                    </a:p>
+                  </a:txBody>
+                  <a:tcPr marL="45720" marR="45720" marT="18288" marB="18288" anchor="ctr">
+                    <a:noFill/>
+                  </a:tcPr>
+                </a:tc>
+                <a:tc>
+                  <a:txBody>
+                    <a:bodyPr/>
+                    <a:lstStyle/>
+                    <a:p>
+                      <a:pPr algn="r"/>
+                      <a:r>
+                        <a:rPr sz="900" b="1">
+                          <a:solidFill>
+                            <a:srgbClr val="B8860B"/>
+                          </a:solidFill>
+                          <a:latin typeface="游ゴシック"/>
+                        </a:rPr>
+                        <a:t>＋6.5％</a:t>
+                      </a:r>
+                    </a:p>
+                  </a:txBody>
+                  <a:tcPr marL="45720" marR="45720" marT="18288" marB="18288" anchor="ctr">
+                    <a:noFill/>
+                  </a:tcPr>
+                </a:tc>
+                <a:tc>
+                  <a:txBody>
+                    <a:bodyPr/>
+                    <a:lstStyle/>
+                    <a:p>
+                      <a:pPr algn="r"/>
+                      <a:r>
+                        <a:rPr sz="900" b="0">
+                          <a:solidFill>
+                            <a:srgbClr val="404040"/>
+                          </a:solidFill>
+                          <a:latin typeface="游ゴシック"/>
+                        </a:rPr>
+                        <a:t>＋7.9％</a:t>
+                      </a:r>
+                    </a:p>
+                  </a:txBody>
+                  <a:tcPr marL="45720" marR="45720" marT="18288" marB="18288" anchor="ctr">
+                    <a:noFill/>
+                  </a:tcPr>
+                </a:tc>
+                <a:tc>
+                  <a:txBody>
+                    <a:bodyPr/>
+                    <a:lstStyle/>
+                    <a:p>
+                      <a:pPr algn="r"/>
+                      <a:r>
+                        <a:rPr sz="900" b="1">
+                          <a:solidFill>
+                            <a:srgbClr val="C00000"/>
+                          </a:solidFill>
+                          <a:latin typeface="游ゴシック"/>
+                        </a:rPr>
+                        <a:t>▲1.4pt</a:t>
+                      </a:r>
+                    </a:p>
+                  </a:txBody>
+                  <a:tcPr marL="45720" marR="45720" marT="18288" marB="18288" anchor="ctr">
+                    <a:noFill/>
+                  </a:tcPr>
+                </a:tc>
+              </a:tr>
+              <a:tr h="265176">
+                <a:tc>
+                  <a:txBody>
+                    <a:bodyPr/>
+                    <a:lstStyle/>
+                    <a:p>
+                      <a:pPr algn="l"/>
+                      <a:r>
+                        <a:rPr sz="900" b="0">
+                          <a:solidFill>
+                            <a:srgbClr val="404040"/>
+                          </a:solidFill>
+                          <a:latin typeface="游ゴシック"/>
+                        </a:rPr>
+                        <a:t>消耗品</a:t>
+                      </a:r>
+                    </a:p>
+                  </a:txBody>
+                  <a:tcPr marL="45720" marR="45720" marT="18288" marB="18288" anchor="ctr">
+                    <a:solidFill>
+                      <a:srgbClr val="F2F2F2"/>
+                    </a:solidFill>
+                  </a:tcPr>
+                </a:tc>
+                <a:tc>
+                  <a:txBody>
+                    <a:bodyPr/>
+                    <a:lstStyle/>
+                    <a:p>
+                      <a:pPr algn="r"/>
+                      <a:r>
+                        <a:rPr sz="900" b="0">
+                          <a:solidFill>
+                            <a:srgbClr val="404040"/>
+                          </a:solidFill>
+                          <a:latin typeface="游ゴシック"/>
+                        </a:rPr>
+                        <a:t>▲9.9％</a:t>
+                      </a:r>
+                    </a:p>
+                  </a:txBody>
+                  <a:tcPr marL="45720" marR="45720" marT="18288" marB="18288" anchor="ctr">
+                    <a:solidFill>
+                      <a:srgbClr val="F2F2F2"/>
+                    </a:solidFill>
+                  </a:tcPr>
+                </a:tc>
+                <a:tc>
+                  <a:txBody>
+                    <a:bodyPr/>
+                    <a:lstStyle/>
+                    <a:p>
+                      <a:pPr algn="r"/>
+                      <a:r>
+                        <a:rPr sz="900" b="1">
+                          <a:solidFill>
+                            <a:srgbClr val="B8860B"/>
+                          </a:solidFill>
+                          <a:latin typeface="游ゴシック"/>
+                        </a:rPr>
+                        <a:t>＋13.2％</a:t>
+                      </a:r>
+                    </a:p>
+                  </a:txBody>
+                  <a:tcPr marL="45720" marR="45720" marT="18288" marB="18288" anchor="ctr">
+                    <a:solidFill>
+                      <a:srgbClr val="F2F2F2"/>
+                    </a:solidFill>
+                  </a:tcPr>
+                </a:tc>
+                <a:tc>
+                  <a:txBody>
+                    <a:bodyPr/>
+                    <a:lstStyle/>
+                    <a:p>
+                      <a:pPr algn="r"/>
+                      <a:r>
+                        <a:rPr sz="900" b="0">
+                          <a:solidFill>
+                            <a:srgbClr val="404040"/>
+                          </a:solidFill>
+                          <a:latin typeface="游ゴシック"/>
+                        </a:rPr>
+                        <a:t>＋11.4％</a:t>
+                      </a:r>
+                    </a:p>
+                  </a:txBody>
+                  <a:tcPr marL="45720" marR="45720" marT="18288" marB="18288" anchor="ctr">
+                    <a:solidFill>
+                      <a:srgbClr val="F2F2F2"/>
+                    </a:solidFill>
+                  </a:tcPr>
+                </a:tc>
+                <a:tc>
+                  <a:txBody>
+                    <a:bodyPr/>
+                    <a:lstStyle/>
+                    <a:p>
+                      <a:pPr algn="r"/>
+                      <a:r>
+                        <a:rPr sz="900" b="1">
+                          <a:solidFill>
+                            <a:srgbClr val="2E7D32"/>
+                          </a:solidFill>
+                          <a:latin typeface="游ゴシック"/>
+                        </a:rPr>
+                        <a:t>＋1.8pt</a:t>
+                      </a:r>
+                    </a:p>
+                  </a:txBody>
+                  <a:tcPr marL="45720" marR="45720" marT="18288" marB="18288" anchor="ctr">
+                    <a:solidFill>
+                      <a:srgbClr val="F2F2F2"/>
+                    </a:solidFill>
+                  </a:tcPr>
+                </a:tc>
+              </a:tr>
+              <a:tr h="265176">
+                <a:tc>
+                  <a:txBody>
+                    <a:bodyPr/>
+                    <a:lstStyle/>
+                    <a:p>
+                      <a:pPr algn="l"/>
+                      <a:r>
+                        <a:rPr sz="900" b="0">
+                          <a:solidFill>
+                            <a:srgbClr val="404040"/>
+                          </a:solidFill>
+                          <a:latin typeface="游ゴシック"/>
+                        </a:rPr>
+                        <a:t>荷役</a:t>
+                      </a:r>
+                    </a:p>
+                  </a:txBody>
+                  <a:tcPr marL="45720" marR="45720" marT="18288" marB="18288" anchor="ctr">
+                    <a:noFill/>
+                  </a:tcPr>
+                </a:tc>
+                <a:tc>
+                  <a:txBody>
+                    <a:bodyPr/>
+                    <a:lstStyle/>
+                    <a:p>
+                      <a:pPr algn="r"/>
+                      <a:r>
+                        <a:rPr sz="900" b="0">
+                          <a:solidFill>
+                            <a:srgbClr val="404040"/>
+                          </a:solidFill>
+                          <a:latin typeface="游ゴシック"/>
+                        </a:rPr>
+                        <a:t>▲9.5％</a:t>
+                      </a:r>
+                    </a:p>
+                  </a:txBody>
+                  <a:tcPr marL="45720" marR="45720" marT="18288" marB="18288" anchor="ctr">
+                    <a:noFill/>
+                  </a:tcPr>
+                </a:tc>
+                <a:tc>
+                  <a:txBody>
+                    <a:bodyPr/>
+                    <a:lstStyle/>
+                    <a:p>
+                      <a:pPr algn="r"/>
+                      <a:r>
+                        <a:rPr sz="900" b="1">
+                          <a:solidFill>
+                            <a:srgbClr val="B8860B"/>
+                          </a:solidFill>
+                          <a:latin typeface="游ゴシック"/>
+                        </a:rPr>
+                        <a:t>＋2.1％</a:t>
+                      </a:r>
+                    </a:p>
+                  </a:txBody>
+                  <a:tcPr marL="45720" marR="45720" marT="18288" marB="18288" anchor="ctr">
+                    <a:noFill/>
+                  </a:tcPr>
+                </a:tc>
+                <a:tc>
+                  <a:txBody>
+                    <a:bodyPr/>
+                    <a:lstStyle/>
+                    <a:p>
+                      <a:pPr algn="r"/>
+                      <a:r>
+                        <a:rPr sz="900" b="0">
+                          <a:solidFill>
+                            <a:srgbClr val="404040"/>
+                          </a:solidFill>
+                          <a:latin typeface="游ゴシック"/>
+                        </a:rPr>
+                        <a:t>▲7.5％</a:t>
+                      </a:r>
+                    </a:p>
+                  </a:txBody>
+                  <a:tcPr marL="45720" marR="45720" marT="18288" marB="18288" anchor="ctr">
+                    <a:noFill/>
+                  </a:tcPr>
+                </a:tc>
+                <a:tc>
+                  <a:txBody>
+                    <a:bodyPr/>
+                    <a:lstStyle/>
+                    <a:p>
+                      <a:pPr algn="r"/>
+                      <a:r>
+                        <a:rPr sz="900" b="1">
+                          <a:solidFill>
+                            <a:srgbClr val="2E7D32"/>
+                          </a:solidFill>
+                          <a:latin typeface="游ゴシック"/>
+                        </a:rPr>
+                        <a:t>＋9.6pt</a:t>
+                      </a:r>
+                    </a:p>
+                  </a:txBody>
+                  <a:tcPr marL="45720" marR="45720" marT="18288" marB="18288" anchor="ctr">
+                    <a:noFill/>
+                  </a:tcPr>
+                </a:tc>
+              </a:tr>
+              <a:tr h="265176">
+                <a:tc>
+                  <a:txBody>
+                    <a:bodyPr/>
+                    <a:lstStyle/>
+                    <a:p>
+                      <a:pPr algn="l"/>
+                      <a:r>
+                        <a:rPr sz="900" b="0">
+                          <a:solidFill>
+                            <a:srgbClr val="404040"/>
+                          </a:solidFill>
+                          <a:latin typeface="游ゴシック"/>
+                        </a:rPr>
+                        <a:t>その他</a:t>
+                      </a:r>
+                    </a:p>
+                  </a:txBody>
+                  <a:tcPr marL="45720" marR="45720" marT="18288" marB="18288" anchor="ctr">
+                    <a:solidFill>
+                      <a:srgbClr val="F2F2F2"/>
+                    </a:solidFill>
+                  </a:tcPr>
+                </a:tc>
+                <a:tc>
+                  <a:txBody>
+                    <a:bodyPr/>
+                    <a:lstStyle/>
+                    <a:p>
+                      <a:pPr algn="r"/>
+                      <a:r>
+                        <a:rPr sz="900" b="0">
+                          <a:solidFill>
+                            <a:srgbClr val="404040"/>
+                          </a:solidFill>
+                          <a:latin typeface="游ゴシック"/>
+                        </a:rPr>
+                        <a:t>＋5.3％</a:t>
+                      </a:r>
+                    </a:p>
+                  </a:txBody>
+                  <a:tcPr marL="45720" marR="45720" marT="18288" marB="18288" anchor="ctr">
+                    <a:solidFill>
+                      <a:srgbClr val="F2F2F2"/>
+                    </a:solidFill>
+                  </a:tcPr>
+                </a:tc>
+                <a:tc>
+                  <a:txBody>
+                    <a:bodyPr/>
+                    <a:lstStyle/>
+                    <a:p>
+                      <a:pPr algn="r"/>
+                      <a:r>
+                        <a:rPr sz="900" b="1">
+                          <a:solidFill>
+                            <a:srgbClr val="B8860B"/>
+                          </a:solidFill>
+                          <a:latin typeface="游ゴシック"/>
+                        </a:rPr>
+                        <a:t>＋14.0％</a:t>
+                      </a:r>
+                    </a:p>
+                  </a:txBody>
+                  <a:tcPr marL="45720" marR="45720" marT="18288" marB="18288" anchor="ctr">
+                    <a:solidFill>
+                      <a:srgbClr val="F2F2F2"/>
+                    </a:solidFill>
+                  </a:tcPr>
+                </a:tc>
+                <a:tc>
+                  <a:txBody>
+                    <a:bodyPr/>
+                    <a:lstStyle/>
+                    <a:p>
+                      <a:pPr algn="r"/>
+                      <a:r>
+                        <a:rPr sz="900" b="0">
+                          <a:solidFill>
+                            <a:srgbClr val="404040"/>
+                          </a:solidFill>
+                          <a:latin typeface="游ゴシック"/>
+                        </a:rPr>
+                        <a:t>＋18.6％</a:t>
+                      </a:r>
+                    </a:p>
+                  </a:txBody>
+                  <a:tcPr marL="45720" marR="45720" marT="18288" marB="18288" anchor="ctr">
+                    <a:solidFill>
+                      <a:srgbClr val="F2F2F2"/>
+                    </a:solidFill>
+                  </a:tcPr>
+                </a:tc>
+                <a:tc>
+                  <a:txBody>
+                    <a:bodyPr/>
+                    <a:lstStyle/>
+                    <a:p>
+                      <a:pPr algn="r"/>
+                      <a:r>
+                        <a:rPr sz="900" b="1">
+                          <a:solidFill>
+                            <a:srgbClr val="C00000"/>
+                          </a:solidFill>
+                          <a:latin typeface="游ゴシック"/>
+                        </a:rPr>
+                        <a:t>▲4.6pt</a:t>
+                      </a:r>
+                    </a:p>
+                  </a:txBody>
+                  <a:tcPr marL="45720" marR="45720" marT="18288" marB="18288" anchor="ctr">
+                    <a:solidFill>
+                      <a:srgbClr val="F2F2F2"/>
+                    </a:solidFill>
+                  </a:tcPr>
+                </a:tc>
+              </a:tr>
+              <a:tr h="265176">
+                <a:tc>
+                  <a:txBody>
+                    <a:bodyPr/>
+                    <a:lstStyle/>
+                    <a:p>
+                      <a:pPr algn="l"/>
+                      <a:r>
+                        <a:rPr sz="900" b="1">
+                          <a:solidFill>
+                            <a:srgbClr val="404040"/>
+                          </a:solidFill>
+                          <a:latin typeface="游ゴシック"/>
+                        </a:rPr>
+                        <a:t>全体（機械類除く）</a:t>
+                      </a:r>
+                    </a:p>
+                  </a:txBody>
+                  <a:tcPr marL="45720" marR="45720" marT="18288" marB="18288" anchor="ctr">
+                    <a:solidFill>
+                      <a:srgbClr val="E8EEF7"/>
+                    </a:solidFill>
+                  </a:tcPr>
+                </a:tc>
+                <a:tc>
+                  <a:txBody>
+                    <a:bodyPr/>
+                    <a:lstStyle/>
+                    <a:p>
+                      <a:pPr algn="r"/>
+                      <a:r>
+                        <a:rPr sz="900" b="1">
+                          <a:solidFill>
+                            <a:srgbClr val="404040"/>
+                          </a:solidFill>
+                          <a:latin typeface="游ゴシック"/>
+                        </a:rPr>
+                        <a:t>＋7.5％</a:t>
+                      </a:r>
+                    </a:p>
+                  </a:txBody>
+                  <a:tcPr marL="45720" marR="45720" marT="18288" marB="18288" anchor="ctr">
+                    <a:solidFill>
+                      <a:srgbClr val="E8EEF7"/>
+                    </a:solidFill>
+                  </a:tcPr>
+                </a:tc>
+                <a:tc>
+                  <a:txBody>
+                    <a:bodyPr/>
+                    <a:lstStyle/>
+                    <a:p>
+                      <a:pPr algn="r"/>
+                      <a:r>
+                        <a:rPr sz="900" b="1">
+                          <a:solidFill>
+                            <a:srgbClr val="B8860B"/>
+                          </a:solidFill>
+                          <a:latin typeface="游ゴシック"/>
+                        </a:rPr>
+                        <a:t>＋17.5％</a:t>
+                      </a:r>
+                    </a:p>
+                  </a:txBody>
+                  <a:tcPr marL="45720" marR="45720" marT="18288" marB="18288" anchor="ctr">
+                    <a:solidFill>
+                      <a:srgbClr val="E8EEF7"/>
+                    </a:solidFill>
+                  </a:tcPr>
+                </a:tc>
+                <a:tc>
+                  <a:txBody>
+                    <a:bodyPr/>
+                    <a:lstStyle/>
+                    <a:p>
+                      <a:pPr algn="r"/>
+                      <a:r>
+                        <a:rPr sz="900" b="1">
+                          <a:solidFill>
+                            <a:srgbClr val="404040"/>
+                          </a:solidFill>
+                          <a:latin typeface="游ゴシック"/>
+                        </a:rPr>
+                        <a:t>＋19.6％</a:t>
+                      </a:r>
+                    </a:p>
+                  </a:txBody>
+                  <a:tcPr marL="45720" marR="45720" marT="18288" marB="18288" anchor="ctr">
+                    <a:solidFill>
+                      <a:srgbClr val="E8EEF7"/>
+                    </a:solidFill>
+                  </a:tcPr>
+                </a:tc>
+                <a:tc>
+                  <a:txBody>
+                    <a:bodyPr/>
+                    <a:lstStyle/>
+                    <a:p>
+                      <a:pPr algn="r"/>
+                      <a:r>
+                        <a:rPr sz="900" b="1">
+                          <a:solidFill>
+                            <a:srgbClr val="C00000"/>
+                          </a:solidFill>
+                          <a:latin typeface="游ゴシック"/>
+                        </a:rPr>
+                        <a:t>▲2.0pt</a:t>
+                      </a:r>
+                    </a:p>
+                  </a:txBody>
+                  <a:tcPr marL="45720" marR="45720" marT="18288" marB="18288" anchor="ctr">
+                    <a:solidFill>
+                      <a:srgbClr val="E8EEF7"/>
+                    </a:solidFill>
+                  </a:tcPr>
+                </a:tc>
+              </a:tr>
+            </a:tbl>
+          </a:graphicData>
+        </a:graphic>
+      </p:graphicFrame>
+      <p:sp>
+        <p:nvSpPr>
+          <p:cNvPr id="14" name="TextBox 13"/>
+          <p:cNvSpPr txBox="1"/>
+          <p:nvPr/>
+        </p:nvSpPr>
+        <p:spPr>
+          <a:xfrm>
+            <a:off x="6199632" y="1097280"/>
+            <a:ext cx="5577840" cy="274320"/>
+          </a:xfrm>
+          <a:prstGeom prst="rect">
+            <a:avLst/>
+          </a:prstGeom>
+          <a:noFill/>
+        </p:spPr>
+        <p:txBody>
+          <a:bodyPr wrap="none" lIns="0">
+            <a:spAutoFit/>
+          </a:bodyPr>
+          <a:lstStyle/>
+          <a:p>
+            <a:r>
+              <a:rPr sz="1100" b="1">
+                <a:solidFill>
+                  <a:srgbClr val="1F3864"/>
+                </a:solidFill>
+                <a:latin typeface="游ゴシック"/>
+              </a:rPr>
+              <a:t>主要分類 ―― 平均単価が使える分類と、使えない分類</a:t>
+            </a:r>
+          </a:p>
+        </p:txBody>
+      </p:sp>
+      <p:graphicFrame>
+        <p:nvGraphicFramePr>
+          <p:cNvPr id="15" name="Table 14"/>
+          <p:cNvGraphicFramePr>
+            <a:graphicFrameLocks noGrp="1"/>
+          </p:cNvGraphicFramePr>
+          <p:nvPr/>
+        </p:nvGraphicFramePr>
+        <p:xfrm>
+          <a:off x="6199632" y="1389888"/>
+          <a:ext cx="5577837" cy="2633472"/>
+        </p:xfrm>
+        <a:graphic>
+          <a:graphicData uri="http://schemas.openxmlformats.org/drawingml/2006/table">
+            <a:tbl>
+              <a:tblPr firstRow="0" bandRow="0"/>
+              <a:tblGrid>
+                <a:gridCol w="1394459"/>
+                <a:gridCol w="861284"/>
+                <a:gridCol w="820270"/>
+                <a:gridCol w="861284"/>
+                <a:gridCol w="738243"/>
+                <a:gridCol w="902297"/>
+              </a:tblGrid>
+              <a:tr h="347472">
+                <a:tc>
+                  <a:txBody>
+                    <a:bodyPr/>
+                    <a:lstStyle/>
+                    <a:p>
+                      <a:pPr algn="ctr"/>
+                      <a:r>
+                        <a:rPr sz="800" b="1">
+                          <a:solidFill>
+                            <a:srgbClr val="FFFFFF"/>
+                          </a:solidFill>
+                          <a:latin typeface="游ゴシック"/>
+                        </a:rPr>
+                        <a:t>分類</a:t>
+                      </a:r>
+                    </a:p>
+                  </a:txBody>
+                  <a:tcPr marL="45720" marR="45720" marT="18288" marB="18288" anchor="ctr">
+                    <a:solidFill>
+                      <a:srgbClr val="1F3864"/>
+                    </a:solidFill>
+                  </a:tcPr>
+                </a:tc>
+                <a:tc>
+                  <a:txBody>
+                    <a:bodyPr/>
+                    <a:lstStyle/>
+                    <a:p>
+                      <a:pPr algn="ctr"/>
+                      <a:r>
+                        <a:rPr sz="800" b="1">
+                          <a:solidFill>
+                            <a:srgbClr val="FFFFFF"/>
+                          </a:solidFill>
+                          <a:latin typeface="游ゴシック"/>
+                        </a:rPr>
+                        <a:t>平均単価
+変化</a:t>
+                      </a:r>
+                    </a:p>
+                  </a:txBody>
+                  <a:tcPr marL="45720" marR="45720" marT="18288" marB="18288" anchor="ctr">
+                    <a:solidFill>
+                      <a:srgbClr val="1F3864"/>
+                    </a:solidFill>
+                  </a:tcPr>
+                </a:tc>
+                <a:tc>
+                  <a:txBody>
+                    <a:bodyPr/>
+                    <a:lstStyle/>
+                    <a:p>
+                      <a:pPr algn="ctr"/>
+                      <a:r>
+                        <a:rPr sz="800" b="1">
+                          <a:solidFill>
+                            <a:srgbClr val="FFFFFF"/>
+                          </a:solidFill>
+                          <a:latin typeface="游ゴシック"/>
+                        </a:rPr>
+                        <a:t>突合
+単価効果</a:t>
+                      </a:r>
+                    </a:p>
+                  </a:txBody>
+                  <a:tcPr marL="45720" marR="45720" marT="18288" marB="18288" anchor="ctr">
+                    <a:solidFill>
+                      <a:srgbClr val="1F3864"/>
+                    </a:solidFill>
+                  </a:tcPr>
+                </a:tc>
+                <a:tc>
+                  <a:txBody>
+                    <a:bodyPr/>
+                    <a:lstStyle/>
+                    <a:p>
+                      <a:pPr algn="ctr"/>
+                      <a:r>
+                        <a:rPr sz="800" b="1">
+                          <a:solidFill>
+                            <a:srgbClr val="FFFFFF"/>
+                          </a:solidFill>
+                          <a:latin typeface="游ゴシック"/>
+                        </a:rPr>
+                        <a:t>差</a:t>
+                      </a:r>
+                    </a:p>
+                  </a:txBody>
+                  <a:tcPr marL="45720" marR="45720" marT="18288" marB="18288" anchor="ctr">
+                    <a:solidFill>
+                      <a:srgbClr val="1F3864"/>
+                    </a:solidFill>
+                  </a:tcPr>
+                </a:tc>
+                <a:tc>
+                  <a:txBody>
+                    <a:bodyPr/>
+                    <a:lstStyle/>
+                    <a:p>
+                      <a:pPr algn="ctr"/>
+                      <a:r>
+                        <a:rPr sz="800" b="1">
+                          <a:solidFill>
+                            <a:srgbClr val="FFFFFF"/>
+                          </a:solidFill>
+                          <a:latin typeface="游ゴシック"/>
+                        </a:rPr>
+                        <a:t>単価の
+散らばり</a:t>
+                      </a:r>
+                    </a:p>
+                  </a:txBody>
+                  <a:tcPr marL="45720" marR="45720" marT="18288" marB="18288" anchor="ctr">
+                    <a:solidFill>
+                      <a:srgbClr val="1F3864"/>
+                    </a:solidFill>
+                  </a:tcPr>
+                </a:tc>
+                <a:tc>
+                  <a:txBody>
+                    <a:bodyPr/>
+                    <a:lstStyle/>
+                    <a:p>
+                      <a:pPr algn="ctr"/>
+                      <a:r>
+                        <a:rPr sz="800" b="1">
+                          <a:solidFill>
+                            <a:srgbClr val="FFFFFF"/>
+                          </a:solidFill>
+                          <a:latin typeface="游ゴシック"/>
+                        </a:rPr>
+                        <a:t>判定</a:t>
+                      </a:r>
+                    </a:p>
+                  </a:txBody>
+                  <a:tcPr marL="45720" marR="45720" marT="18288" marB="18288" anchor="ctr">
+                    <a:solidFill>
+                      <a:srgbClr val="1F3864"/>
+                    </a:solidFill>
+                  </a:tcPr>
+                </a:tc>
+              </a:tr>
+              <a:tr h="228600">
+                <a:tc>
+                  <a:txBody>
+                    <a:bodyPr/>
+                    <a:lstStyle/>
+                    <a:p>
+                      <a:pPr algn="l"/>
+                      <a:r>
+                        <a:rPr sz="900" b="0">
+                          <a:solidFill>
+                            <a:srgbClr val="404040"/>
+                          </a:solidFill>
+                          <a:latin typeface="游ゴシック"/>
+                        </a:rPr>
+                        <a:t>トレー</a:t>
+                      </a:r>
+                    </a:p>
+                  </a:txBody>
+                  <a:tcPr marL="45720" marR="45720" marT="18288" marB="18288" anchor="ctr">
+                    <a:noFill/>
+                  </a:tcPr>
+                </a:tc>
+                <a:tc>
+                  <a:txBody>
+                    <a:bodyPr/>
+                    <a:lstStyle/>
+                    <a:p>
+                      <a:pPr algn="r"/>
+                      <a:r>
+                        <a:rPr sz="900" b="0">
+                          <a:solidFill>
+                            <a:srgbClr val="404040"/>
+                          </a:solidFill>
+                          <a:latin typeface="游ゴシック"/>
+                        </a:rPr>
+                        <a:t>＋8.1％</a:t>
+                      </a:r>
+                    </a:p>
+                  </a:txBody>
+                  <a:tcPr marL="45720" marR="45720" marT="18288" marB="18288" anchor="ctr">
+                    <a:noFill/>
+                  </a:tcPr>
+                </a:tc>
+                <a:tc>
+                  <a:txBody>
+                    <a:bodyPr/>
+                    <a:lstStyle/>
+                    <a:p>
+                      <a:pPr algn="r"/>
+                      <a:r>
+                        <a:rPr sz="900" b="0">
+                          <a:solidFill>
+                            <a:srgbClr val="404040"/>
+                          </a:solidFill>
+                          <a:latin typeface="游ゴシック"/>
+                        </a:rPr>
+                        <a:t>＋22.5％</a:t>
+                      </a:r>
+                    </a:p>
+                  </a:txBody>
+                  <a:tcPr marL="45720" marR="45720" marT="18288" marB="18288" anchor="ctr">
+                    <a:noFill/>
+                  </a:tcPr>
+                </a:tc>
+                <a:tc>
+                  <a:txBody>
+                    <a:bodyPr/>
+                    <a:lstStyle/>
+                    <a:p>
+                      <a:pPr algn="r"/>
+                      <a:r>
+                        <a:rPr sz="900" b="1">
+                          <a:solidFill>
+                            <a:srgbClr val="C00000"/>
+                          </a:solidFill>
+                          <a:latin typeface="游ゴシック"/>
+                        </a:rPr>
+                        <a:t>▲14.3pt</a:t>
+                      </a:r>
+                    </a:p>
+                  </a:txBody>
+                  <a:tcPr marL="45720" marR="45720" marT="18288" marB="18288" anchor="ctr">
+                    <a:noFill/>
+                  </a:tcPr>
+                </a:tc>
+                <a:tc>
+                  <a:txBody>
+                    <a:bodyPr/>
+                    <a:lstStyle/>
+                    <a:p>
+                      <a:pPr algn="r"/>
+                      <a:r>
+                        <a:rPr sz="900" b="0">
+                          <a:solidFill>
+                            <a:srgbClr val="404040"/>
+                          </a:solidFill>
+                          <a:latin typeface="游ゴシック"/>
+                        </a:rPr>
+                        <a:t>5倍</a:t>
+                      </a:r>
+                    </a:p>
+                  </a:txBody>
+                  <a:tcPr marL="45720" marR="45720" marT="18288" marB="18288" anchor="ctr">
+                    <a:noFill/>
+                  </a:tcPr>
+                </a:tc>
+                <a:tc>
+                  <a:txBody>
+                    <a:bodyPr/>
+                    <a:lstStyle/>
+                    <a:p>
+                      <a:pPr algn="ctr"/>
+                      <a:r>
+                        <a:rPr sz="900" b="1">
+                          <a:solidFill>
+                            <a:srgbClr val="2E7D32"/>
+                          </a:solidFill>
+                          <a:latin typeface="游ゴシック"/>
+                        </a:rPr>
+                        <a:t>○ 平均単価</a:t>
+                      </a:r>
+                    </a:p>
+                  </a:txBody>
+                  <a:tcPr marL="45720" marR="45720" marT="18288" marB="18288" anchor="ctr">
+                    <a:noFill/>
+                  </a:tcPr>
+                </a:tc>
+              </a:tr>
+              <a:tr h="228600">
+                <a:tc>
+                  <a:txBody>
+                    <a:bodyPr/>
+                    <a:lstStyle/>
+                    <a:p>
+                      <a:pPr algn="l"/>
+                      <a:r>
+                        <a:rPr sz="900" b="0">
+                          <a:solidFill>
+                            <a:srgbClr val="404040"/>
+                          </a:solidFill>
+                          <a:latin typeface="游ゴシック"/>
+                        </a:rPr>
+                        <a:t>発泡スチロール</a:t>
+                      </a:r>
+                    </a:p>
+                  </a:txBody>
+                  <a:tcPr marL="45720" marR="45720" marT="18288" marB="18288" anchor="ctr">
+                    <a:solidFill>
+                      <a:srgbClr val="F2F2F2"/>
+                    </a:solidFill>
+                  </a:tcPr>
+                </a:tc>
+                <a:tc>
+                  <a:txBody>
+                    <a:bodyPr/>
+                    <a:lstStyle/>
+                    <a:p>
+                      <a:pPr algn="r"/>
+                      <a:r>
+                        <a:rPr sz="900" b="0">
+                          <a:solidFill>
+                            <a:srgbClr val="404040"/>
+                          </a:solidFill>
+                          <a:latin typeface="游ゴシック"/>
+                        </a:rPr>
+                        <a:t>＋43.5％</a:t>
+                      </a:r>
+                    </a:p>
+                  </a:txBody>
+                  <a:tcPr marL="45720" marR="45720" marT="18288" marB="18288" anchor="ctr">
+                    <a:solidFill>
+                      <a:srgbClr val="F2F2F2"/>
+                    </a:solidFill>
+                  </a:tcPr>
+                </a:tc>
+                <a:tc>
+                  <a:txBody>
+                    <a:bodyPr/>
+                    <a:lstStyle/>
+                    <a:p>
+                      <a:pPr algn="r"/>
+                      <a:r>
+                        <a:rPr sz="900" b="0">
+                          <a:solidFill>
+                            <a:srgbClr val="404040"/>
+                          </a:solidFill>
+                          <a:latin typeface="游ゴシック"/>
+                        </a:rPr>
+                        <a:t>＋26.5％</a:t>
+                      </a:r>
+                    </a:p>
+                  </a:txBody>
+                  <a:tcPr marL="45720" marR="45720" marT="18288" marB="18288" anchor="ctr">
+                    <a:solidFill>
+                      <a:srgbClr val="F2F2F2"/>
+                    </a:solidFill>
+                  </a:tcPr>
+                </a:tc>
+                <a:tc>
+                  <a:txBody>
+                    <a:bodyPr/>
+                    <a:lstStyle/>
+                    <a:p>
+                      <a:pPr algn="r"/>
+                      <a:r>
+                        <a:rPr sz="900" b="1">
+                          <a:solidFill>
+                            <a:srgbClr val="2E7D32"/>
+                          </a:solidFill>
+                          <a:latin typeface="游ゴシック"/>
+                        </a:rPr>
+                        <a:t>＋16.9pt</a:t>
+                      </a:r>
+                    </a:p>
+                  </a:txBody>
+                  <a:tcPr marL="45720" marR="45720" marT="18288" marB="18288" anchor="ctr">
+                    <a:solidFill>
+                      <a:srgbClr val="F2F2F2"/>
+                    </a:solidFill>
+                  </a:tcPr>
+                </a:tc>
+                <a:tc>
+                  <a:txBody>
+                    <a:bodyPr/>
+                    <a:lstStyle/>
+                    <a:p>
+                      <a:pPr algn="r"/>
+                      <a:r>
+                        <a:rPr sz="900" b="0">
+                          <a:solidFill>
+                            <a:srgbClr val="404040"/>
+                          </a:solidFill>
+                          <a:latin typeface="游ゴシック"/>
+                        </a:rPr>
+                        <a:t>4倍</a:t>
+                      </a:r>
+                    </a:p>
+                  </a:txBody>
+                  <a:tcPr marL="45720" marR="45720" marT="18288" marB="18288" anchor="ctr">
+                    <a:solidFill>
+                      <a:srgbClr val="F2F2F2"/>
+                    </a:solidFill>
+                  </a:tcPr>
+                </a:tc>
+                <a:tc>
+                  <a:txBody>
+                    <a:bodyPr/>
+                    <a:lstStyle/>
+                    <a:p>
+                      <a:pPr algn="ctr"/>
+                      <a:r>
+                        <a:rPr sz="900" b="1">
+                          <a:solidFill>
+                            <a:srgbClr val="2E7D32"/>
+                          </a:solidFill>
+                          <a:latin typeface="游ゴシック"/>
+                        </a:rPr>
+                        <a:t>○ 平均単価</a:t>
+                      </a:r>
+                    </a:p>
+                  </a:txBody>
+                  <a:tcPr marL="45720" marR="45720" marT="18288" marB="18288" anchor="ctr">
+                    <a:solidFill>
+                      <a:srgbClr val="F2F2F2"/>
+                    </a:solidFill>
+                  </a:tcPr>
+                </a:tc>
+              </a:tr>
+              <a:tr h="228600">
+                <a:tc>
+                  <a:txBody>
+                    <a:bodyPr/>
+                    <a:lstStyle/>
+                    <a:p>
+                      <a:pPr algn="l"/>
+                      <a:r>
+                        <a:rPr sz="900" b="0">
+                          <a:solidFill>
+                            <a:srgbClr val="404040"/>
+                          </a:solidFill>
+                          <a:latin typeface="游ゴシック"/>
+                        </a:rPr>
+                        <a:t>段ボール</a:t>
+                      </a:r>
+                    </a:p>
+                  </a:txBody>
+                  <a:tcPr marL="45720" marR="45720" marT="18288" marB="18288" anchor="ctr">
+                    <a:noFill/>
+                  </a:tcPr>
+                </a:tc>
+                <a:tc>
+                  <a:txBody>
+                    <a:bodyPr/>
+                    <a:lstStyle/>
+                    <a:p>
+                      <a:pPr algn="r"/>
+                      <a:r>
+                        <a:rPr sz="900" b="0">
+                          <a:solidFill>
+                            <a:srgbClr val="404040"/>
+                          </a:solidFill>
+                          <a:latin typeface="游ゴシック"/>
+                        </a:rPr>
+                        <a:t>＋2.4％</a:t>
+                      </a:r>
+                    </a:p>
+                  </a:txBody>
+                  <a:tcPr marL="45720" marR="45720" marT="18288" marB="18288" anchor="ctr">
+                    <a:noFill/>
+                  </a:tcPr>
+                </a:tc>
+                <a:tc>
+                  <a:txBody>
+                    <a:bodyPr/>
+                    <a:lstStyle/>
+                    <a:p>
+                      <a:pPr algn="r"/>
+                      <a:r>
+                        <a:rPr sz="900" b="0">
+                          <a:solidFill>
+                            <a:srgbClr val="404040"/>
+                          </a:solidFill>
+                          <a:latin typeface="游ゴシック"/>
+                        </a:rPr>
+                        <a:t>＋6.7％</a:t>
+                      </a:r>
+                    </a:p>
+                  </a:txBody>
+                  <a:tcPr marL="45720" marR="45720" marT="18288" marB="18288" anchor="ctr">
+                    <a:noFill/>
+                  </a:tcPr>
+                </a:tc>
+                <a:tc>
+                  <a:txBody>
+                    <a:bodyPr/>
+                    <a:lstStyle/>
+                    <a:p>
+                      <a:pPr algn="r"/>
+                      <a:r>
+                        <a:rPr sz="900" b="1">
+                          <a:solidFill>
+                            <a:srgbClr val="C00000"/>
+                          </a:solidFill>
+                          <a:latin typeface="游ゴシック"/>
+                        </a:rPr>
+                        <a:t>▲4.3pt</a:t>
+                      </a:r>
+                    </a:p>
+                  </a:txBody>
+                  <a:tcPr marL="45720" marR="45720" marT="18288" marB="18288" anchor="ctr">
+                    <a:noFill/>
+                  </a:tcPr>
+                </a:tc>
+                <a:tc>
+                  <a:txBody>
+                    <a:bodyPr/>
+                    <a:lstStyle/>
+                    <a:p>
+                      <a:pPr algn="r"/>
+                      <a:r>
+                        <a:rPr sz="900" b="0">
+                          <a:solidFill>
+                            <a:srgbClr val="404040"/>
+                          </a:solidFill>
+                          <a:latin typeface="游ゴシック"/>
+                        </a:rPr>
+                        <a:t>4倍</a:t>
+                      </a:r>
+                    </a:p>
+                  </a:txBody>
+                  <a:tcPr marL="45720" marR="45720" marT="18288" marB="18288" anchor="ctr">
+                    <a:noFill/>
+                  </a:tcPr>
+                </a:tc>
+                <a:tc>
+                  <a:txBody>
+                    <a:bodyPr/>
+                    <a:lstStyle/>
+                    <a:p>
+                      <a:pPr algn="ctr"/>
+                      <a:r>
+                        <a:rPr sz="900" b="1">
+                          <a:solidFill>
+                            <a:srgbClr val="2E7D32"/>
+                          </a:solidFill>
+                          <a:latin typeface="游ゴシック"/>
+                        </a:rPr>
+                        <a:t>○ 平均単価</a:t>
+                      </a:r>
+                    </a:p>
+                  </a:txBody>
+                  <a:tcPr marL="45720" marR="45720" marT="18288" marB="18288" anchor="ctr">
+                    <a:noFill/>
+                  </a:tcPr>
+                </a:tc>
+              </a:tr>
+              <a:tr h="228600">
+                <a:tc>
+                  <a:txBody>
+                    <a:bodyPr/>
+                    <a:lstStyle/>
+                    <a:p>
+                      <a:pPr algn="l"/>
+                      <a:r>
+                        <a:rPr sz="900" b="0">
+                          <a:solidFill>
+                            <a:srgbClr val="404040"/>
+                          </a:solidFill>
+                          <a:latin typeface="游ゴシック"/>
+                        </a:rPr>
+                        <a:t>ＰＰトレー</a:t>
+                      </a:r>
+                    </a:p>
+                  </a:txBody>
+                  <a:tcPr marL="45720" marR="45720" marT="18288" marB="18288" anchor="ctr">
+                    <a:solidFill>
+                      <a:srgbClr val="F2F2F2"/>
+                    </a:solidFill>
+                  </a:tcPr>
+                </a:tc>
+                <a:tc>
+                  <a:txBody>
+                    <a:bodyPr/>
+                    <a:lstStyle/>
+                    <a:p>
+                      <a:pPr algn="r"/>
+                      <a:r>
+                        <a:rPr sz="900" b="0">
+                          <a:solidFill>
+                            <a:srgbClr val="404040"/>
+                          </a:solidFill>
+                          <a:latin typeface="游ゴシック"/>
+                        </a:rPr>
+                        <a:t>＋4.5％</a:t>
+                      </a:r>
+                    </a:p>
+                  </a:txBody>
+                  <a:tcPr marL="45720" marR="45720" marT="18288" marB="18288" anchor="ctr">
+                    <a:solidFill>
+                      <a:srgbClr val="F2F2F2"/>
+                    </a:solidFill>
+                  </a:tcPr>
+                </a:tc>
+                <a:tc>
+                  <a:txBody>
+                    <a:bodyPr/>
+                    <a:lstStyle/>
+                    <a:p>
+                      <a:pPr algn="r"/>
+                      <a:r>
+                        <a:rPr sz="900" b="0">
+                          <a:solidFill>
+                            <a:srgbClr val="404040"/>
+                          </a:solidFill>
+                          <a:latin typeface="游ゴシック"/>
+                        </a:rPr>
+                        <a:t>＋17.7％</a:t>
+                      </a:r>
+                    </a:p>
+                  </a:txBody>
+                  <a:tcPr marL="45720" marR="45720" marT="18288" marB="18288" anchor="ctr">
+                    <a:solidFill>
+                      <a:srgbClr val="F2F2F2"/>
+                    </a:solidFill>
+                  </a:tcPr>
+                </a:tc>
+                <a:tc>
+                  <a:txBody>
+                    <a:bodyPr/>
+                    <a:lstStyle/>
+                    <a:p>
+                      <a:pPr algn="r"/>
+                      <a:r>
+                        <a:rPr sz="900" b="1">
+                          <a:solidFill>
+                            <a:srgbClr val="C00000"/>
+                          </a:solidFill>
+                          <a:latin typeface="游ゴシック"/>
+                        </a:rPr>
+                        <a:t>▲13.2pt</a:t>
+                      </a:r>
+                    </a:p>
+                  </a:txBody>
+                  <a:tcPr marL="45720" marR="45720" marT="18288" marB="18288" anchor="ctr">
+                    <a:solidFill>
+                      <a:srgbClr val="F2F2F2"/>
+                    </a:solidFill>
+                  </a:tcPr>
+                </a:tc>
+                <a:tc>
+                  <a:txBody>
+                    <a:bodyPr/>
+                    <a:lstStyle/>
+                    <a:p>
+                      <a:pPr algn="r"/>
+                      <a:r>
+                        <a:rPr sz="900" b="0">
+                          <a:solidFill>
+                            <a:srgbClr val="404040"/>
+                          </a:solidFill>
+                          <a:latin typeface="游ゴシック"/>
+                        </a:rPr>
+                        <a:t>2倍</a:t>
+                      </a:r>
+                    </a:p>
+                  </a:txBody>
+                  <a:tcPr marL="45720" marR="45720" marT="18288" marB="18288" anchor="ctr">
+                    <a:solidFill>
+                      <a:srgbClr val="F2F2F2"/>
+                    </a:solidFill>
+                  </a:tcPr>
+                </a:tc>
+                <a:tc>
+                  <a:txBody>
+                    <a:bodyPr/>
+                    <a:lstStyle/>
+                    <a:p>
+                      <a:pPr algn="ctr"/>
+                      <a:r>
+                        <a:rPr sz="900" b="1">
+                          <a:solidFill>
+                            <a:srgbClr val="2E7D32"/>
+                          </a:solidFill>
+                          <a:latin typeface="游ゴシック"/>
+                        </a:rPr>
+                        <a:t>○ 平均単価</a:t>
+                      </a:r>
+                    </a:p>
+                  </a:txBody>
+                  <a:tcPr marL="45720" marR="45720" marT="18288" marB="18288" anchor="ctr">
+                    <a:solidFill>
+                      <a:srgbClr val="F2F2F2"/>
+                    </a:solidFill>
+                  </a:tcPr>
+                </a:tc>
+              </a:tr>
+              <a:tr h="228600">
+                <a:tc>
+                  <a:txBody>
+                    <a:bodyPr/>
+                    <a:lstStyle/>
+                    <a:p>
+                      <a:pPr algn="l"/>
+                      <a:r>
+                        <a:rPr sz="900" b="0">
+                          <a:solidFill>
+                            <a:srgbClr val="404040"/>
+                          </a:solidFill>
+                          <a:latin typeface="游ゴシック"/>
+                        </a:rPr>
+                        <a:t>テープ</a:t>
+                      </a:r>
+                    </a:p>
+                  </a:txBody>
+                  <a:tcPr marL="45720" marR="45720" marT="18288" marB="18288" anchor="ctr">
+                    <a:noFill/>
+                  </a:tcPr>
+                </a:tc>
+                <a:tc>
+                  <a:txBody>
+                    <a:bodyPr/>
+                    <a:lstStyle/>
+                    <a:p>
+                      <a:pPr algn="r"/>
+                      <a:r>
+                        <a:rPr sz="900" b="0">
+                          <a:solidFill>
+                            <a:srgbClr val="404040"/>
+                          </a:solidFill>
+                          <a:latin typeface="游ゴシック"/>
+                        </a:rPr>
+                        <a:t>＋39.4％</a:t>
+                      </a:r>
+                    </a:p>
+                  </a:txBody>
+                  <a:tcPr marL="45720" marR="45720" marT="18288" marB="18288" anchor="ctr">
+                    <a:noFill/>
+                  </a:tcPr>
+                </a:tc>
+                <a:tc>
+                  <a:txBody>
+                    <a:bodyPr/>
+                    <a:lstStyle/>
+                    <a:p>
+                      <a:pPr algn="r"/>
+                      <a:r>
+                        <a:rPr sz="900" b="0">
+                          <a:solidFill>
+                            <a:srgbClr val="404040"/>
+                          </a:solidFill>
+                          <a:latin typeface="游ゴシック"/>
+                        </a:rPr>
+                        <a:t>＋18.9％</a:t>
+                      </a:r>
+                    </a:p>
+                  </a:txBody>
+                  <a:tcPr marL="45720" marR="45720" marT="18288" marB="18288" anchor="ctr">
+                    <a:noFill/>
+                  </a:tcPr>
+                </a:tc>
+                <a:tc>
+                  <a:txBody>
+                    <a:bodyPr/>
+                    <a:lstStyle/>
+                    <a:p>
+                      <a:pPr algn="r"/>
+                      <a:r>
+                        <a:rPr sz="900" b="1">
+                          <a:solidFill>
+                            <a:srgbClr val="2E7D32"/>
+                          </a:solidFill>
+                          <a:latin typeface="游ゴシック"/>
+                        </a:rPr>
+                        <a:t>＋20.5pt</a:t>
+                      </a:r>
+                    </a:p>
+                  </a:txBody>
+                  <a:tcPr marL="45720" marR="45720" marT="18288" marB="18288" anchor="ctr">
+                    <a:noFill/>
+                  </a:tcPr>
+                </a:tc>
+                <a:tc>
+                  <a:txBody>
+                    <a:bodyPr/>
+                    <a:lstStyle/>
+                    <a:p>
+                      <a:pPr algn="r"/>
+                      <a:r>
+                        <a:rPr sz="900" b="0">
+                          <a:solidFill>
+                            <a:srgbClr val="404040"/>
+                          </a:solidFill>
+                          <a:latin typeface="游ゴシック"/>
+                        </a:rPr>
+                        <a:t>2倍</a:t>
+                      </a:r>
+                    </a:p>
+                  </a:txBody>
+                  <a:tcPr marL="45720" marR="45720" marT="18288" marB="18288" anchor="ctr">
+                    <a:noFill/>
+                  </a:tcPr>
+                </a:tc>
+                <a:tc>
+                  <a:txBody>
+                    <a:bodyPr/>
+                    <a:lstStyle/>
+                    <a:p>
+                      <a:pPr algn="ctr"/>
+                      <a:r>
+                        <a:rPr sz="900" b="1">
+                          <a:solidFill>
+                            <a:srgbClr val="2E7D32"/>
+                          </a:solidFill>
+                          <a:latin typeface="游ゴシック"/>
+                        </a:rPr>
+                        <a:t>○ 平均単価</a:t>
+                      </a:r>
+                    </a:p>
+                  </a:txBody>
+                  <a:tcPr marL="45720" marR="45720" marT="18288" marB="18288" anchor="ctr">
+                    <a:noFill/>
+                  </a:tcPr>
+                </a:tc>
+              </a:tr>
+              <a:tr h="228600">
+                <a:tc>
+                  <a:txBody>
+                    <a:bodyPr/>
+                    <a:lstStyle/>
+                    <a:p>
+                      <a:pPr algn="l"/>
+                      <a:r>
+                        <a:rPr sz="900" b="0">
+                          <a:solidFill>
+                            <a:srgbClr val="404040"/>
+                          </a:solidFill>
+                          <a:latin typeface="游ゴシック"/>
+                        </a:rPr>
+                        <a:t>バンド類</a:t>
+                      </a:r>
+                    </a:p>
+                  </a:txBody>
+                  <a:tcPr marL="45720" marR="45720" marT="18288" marB="18288" anchor="ctr">
+                    <a:solidFill>
+                      <a:srgbClr val="F2F2F2"/>
+                    </a:solidFill>
+                  </a:tcPr>
+                </a:tc>
+                <a:tc>
+                  <a:txBody>
+                    <a:bodyPr/>
+                    <a:lstStyle/>
+                    <a:p>
+                      <a:pPr algn="r"/>
+                      <a:r>
+                        <a:rPr sz="900" b="0">
+                          <a:solidFill>
+                            <a:srgbClr val="404040"/>
+                          </a:solidFill>
+                          <a:latin typeface="游ゴシック"/>
+                        </a:rPr>
+                        <a:t>＋26.6％</a:t>
+                      </a:r>
+                    </a:p>
+                  </a:txBody>
+                  <a:tcPr marL="45720" marR="45720" marT="18288" marB="18288" anchor="ctr">
+                    <a:solidFill>
+                      <a:srgbClr val="F2F2F2"/>
+                    </a:solidFill>
+                  </a:tcPr>
+                </a:tc>
+                <a:tc>
+                  <a:txBody>
+                    <a:bodyPr/>
+                    <a:lstStyle/>
+                    <a:p>
+                      <a:pPr algn="r"/>
+                      <a:r>
+                        <a:rPr sz="900" b="0">
+                          <a:solidFill>
+                            <a:srgbClr val="404040"/>
+                          </a:solidFill>
+                          <a:latin typeface="游ゴシック"/>
+                        </a:rPr>
+                        <a:t>＋28.6％</a:t>
+                      </a:r>
+                    </a:p>
+                  </a:txBody>
+                  <a:tcPr marL="45720" marR="45720" marT="18288" marB="18288" anchor="ctr">
+                    <a:solidFill>
+                      <a:srgbClr val="F2F2F2"/>
+                    </a:solidFill>
+                  </a:tcPr>
+                </a:tc>
+                <a:tc>
+                  <a:txBody>
+                    <a:bodyPr/>
+                    <a:lstStyle/>
+                    <a:p>
+                      <a:pPr algn="r"/>
+                      <a:r>
+                        <a:rPr sz="900" b="1">
+                          <a:solidFill>
+                            <a:srgbClr val="C00000"/>
+                          </a:solidFill>
+                          <a:latin typeface="游ゴシック"/>
+                        </a:rPr>
+                        <a:t>▲2.0pt</a:t>
+                      </a:r>
+                    </a:p>
+                  </a:txBody>
+                  <a:tcPr marL="45720" marR="45720" marT="18288" marB="18288" anchor="ctr">
+                    <a:solidFill>
+                      <a:srgbClr val="F2F2F2"/>
+                    </a:solidFill>
+                  </a:tcPr>
+                </a:tc>
+                <a:tc>
+                  <a:txBody>
+                    <a:bodyPr/>
+                    <a:lstStyle/>
+                    <a:p>
+                      <a:pPr algn="r"/>
+                      <a:r>
+                        <a:rPr sz="900" b="0">
+                          <a:solidFill>
+                            <a:srgbClr val="404040"/>
+                          </a:solidFill>
+                          <a:latin typeface="游ゴシック"/>
+                        </a:rPr>
+                        <a:t>2倍</a:t>
+                      </a:r>
+                    </a:p>
+                  </a:txBody>
+                  <a:tcPr marL="45720" marR="45720" marT="18288" marB="18288" anchor="ctr">
+                    <a:solidFill>
+                      <a:srgbClr val="F2F2F2"/>
+                    </a:solidFill>
+                  </a:tcPr>
+                </a:tc>
+                <a:tc>
+                  <a:txBody>
+                    <a:bodyPr/>
+                    <a:lstStyle/>
+                    <a:p>
+                      <a:pPr algn="ctr"/>
+                      <a:r>
+                        <a:rPr sz="900" b="1">
+                          <a:solidFill>
+                            <a:srgbClr val="2E7D32"/>
+                          </a:solidFill>
+                          <a:latin typeface="游ゴシック"/>
+                        </a:rPr>
+                        <a:t>○ 平均単価</a:t>
+                      </a:r>
+                    </a:p>
+                  </a:txBody>
+                  <a:tcPr marL="45720" marR="45720" marT="18288" marB="18288" anchor="ctr">
+                    <a:solidFill>
+                      <a:srgbClr val="F2F2F2"/>
+                    </a:solidFill>
+                  </a:tcPr>
+                </a:tc>
+              </a:tr>
+              <a:tr h="228600">
+                <a:tc>
+                  <a:txBody>
+                    <a:bodyPr/>
+                    <a:lstStyle/>
+                    <a:p>
+                      <a:pPr algn="l"/>
+                      <a:r>
+                        <a:rPr sz="900" b="0">
+                          <a:solidFill>
+                            <a:srgbClr val="404040"/>
+                          </a:solidFill>
+                          <a:latin typeface="游ゴシック"/>
+                        </a:rPr>
+                        <a:t>袋類</a:t>
+                      </a:r>
+                    </a:p>
+                  </a:txBody>
+                  <a:tcPr marL="45720" marR="45720" marT="18288" marB="18288" anchor="ctr">
+                    <a:noFill/>
+                  </a:tcPr>
+                </a:tc>
+                <a:tc>
+                  <a:txBody>
+                    <a:bodyPr/>
+                    <a:lstStyle/>
+                    <a:p>
+                      <a:pPr algn="r"/>
+                      <a:r>
+                        <a:rPr sz="900" b="0">
+                          <a:solidFill>
+                            <a:srgbClr val="404040"/>
+                          </a:solidFill>
+                          <a:latin typeface="游ゴシック"/>
+                        </a:rPr>
+                        <a:t>＋30.5％</a:t>
+                      </a:r>
+                    </a:p>
+                  </a:txBody>
+                  <a:tcPr marL="45720" marR="45720" marT="18288" marB="18288" anchor="ctr">
+                    <a:noFill/>
+                  </a:tcPr>
+                </a:tc>
+                <a:tc>
+                  <a:txBody>
+                    <a:bodyPr/>
+                    <a:lstStyle/>
+                    <a:p>
+                      <a:pPr algn="r"/>
+                      <a:r>
+                        <a:rPr sz="900" b="0">
+                          <a:solidFill>
+                            <a:srgbClr val="404040"/>
+                          </a:solidFill>
+                          <a:latin typeface="游ゴシック"/>
+                        </a:rPr>
+                        <a:t>＋27.5％</a:t>
+                      </a:r>
+                    </a:p>
+                  </a:txBody>
+                  <a:tcPr marL="45720" marR="45720" marT="18288" marB="18288" anchor="ctr">
+                    <a:noFill/>
+                  </a:tcPr>
+                </a:tc>
+                <a:tc>
+                  <a:txBody>
+                    <a:bodyPr/>
+                    <a:lstStyle/>
+                    <a:p>
+                      <a:pPr algn="r"/>
+                      <a:r>
+                        <a:rPr sz="900" b="1">
+                          <a:solidFill>
+                            <a:srgbClr val="2E7D32"/>
+                          </a:solidFill>
+                          <a:latin typeface="游ゴシック"/>
+                        </a:rPr>
+                        <a:t>＋3.0pt</a:t>
+                      </a:r>
+                    </a:p>
+                  </a:txBody>
+                  <a:tcPr marL="45720" marR="45720" marT="18288" marB="18288" anchor="ctr">
+                    <a:noFill/>
+                  </a:tcPr>
+                </a:tc>
+                <a:tc>
+                  <a:txBody>
+                    <a:bodyPr/>
+                    <a:lstStyle/>
+                    <a:p>
+                      <a:pPr algn="r"/>
+                      <a:r>
+                        <a:rPr sz="900" b="0">
+                          <a:solidFill>
+                            <a:srgbClr val="404040"/>
+                          </a:solidFill>
+                          <a:latin typeface="游ゴシック"/>
+                        </a:rPr>
+                        <a:t>20倍</a:t>
+                      </a:r>
+                    </a:p>
+                  </a:txBody>
+                  <a:tcPr marL="45720" marR="45720" marT="18288" marB="18288" anchor="ctr">
+                    <a:noFill/>
+                  </a:tcPr>
+                </a:tc>
+                <a:tc>
+                  <a:txBody>
+                    <a:bodyPr/>
+                    <a:lstStyle/>
+                    <a:p>
+                      <a:pPr algn="ctr"/>
+                      <a:r>
+                        <a:rPr sz="900" b="1">
+                          <a:solidFill>
+                            <a:srgbClr val="C00000"/>
+                          </a:solidFill>
+                          <a:latin typeface="游ゴシック"/>
+                        </a:rPr>
+                        <a:t>× 突合のみ</a:t>
+                      </a:r>
+                    </a:p>
+                  </a:txBody>
+                  <a:tcPr marL="45720" marR="45720" marT="18288" marB="18288" anchor="ctr">
+                    <a:noFill/>
+                  </a:tcPr>
+                </a:tc>
+              </a:tr>
+              <a:tr h="228600">
+                <a:tc>
+                  <a:txBody>
+                    <a:bodyPr/>
+                    <a:lstStyle/>
+                    <a:p>
+                      <a:pPr algn="l"/>
+                      <a:r>
+                        <a:rPr sz="900" b="0">
+                          <a:solidFill>
+                            <a:srgbClr val="404040"/>
+                          </a:solidFill>
+                          <a:latin typeface="游ゴシック"/>
+                        </a:rPr>
+                        <a:t>フィルム</a:t>
+                      </a:r>
+                    </a:p>
+                  </a:txBody>
+                  <a:tcPr marL="45720" marR="45720" marT="18288" marB="18288" anchor="ctr">
+                    <a:solidFill>
+                      <a:srgbClr val="F2F2F2"/>
+                    </a:solidFill>
+                  </a:tcPr>
+                </a:tc>
+                <a:tc>
+                  <a:txBody>
+                    <a:bodyPr/>
+                    <a:lstStyle/>
+                    <a:p>
+                      <a:pPr algn="r"/>
+                      <a:r>
+                        <a:rPr sz="900" b="0">
+                          <a:solidFill>
+                            <a:srgbClr val="404040"/>
+                          </a:solidFill>
+                          <a:latin typeface="游ゴシック"/>
+                        </a:rPr>
+                        <a:t>＋25.7％</a:t>
+                      </a:r>
+                    </a:p>
+                  </a:txBody>
+                  <a:tcPr marL="45720" marR="45720" marT="18288" marB="18288" anchor="ctr">
+                    <a:solidFill>
+                      <a:srgbClr val="F2F2F2"/>
+                    </a:solidFill>
+                  </a:tcPr>
+                </a:tc>
+                <a:tc>
+                  <a:txBody>
+                    <a:bodyPr/>
+                    <a:lstStyle/>
+                    <a:p>
+                      <a:pPr algn="r"/>
+                      <a:r>
+                        <a:rPr sz="900" b="0">
+                          <a:solidFill>
+                            <a:srgbClr val="404040"/>
+                          </a:solidFill>
+                          <a:latin typeface="游ゴシック"/>
+                        </a:rPr>
+                        <a:t>＋24.3％</a:t>
+                      </a:r>
+                    </a:p>
+                  </a:txBody>
+                  <a:tcPr marL="45720" marR="45720" marT="18288" marB="18288" anchor="ctr">
+                    <a:solidFill>
+                      <a:srgbClr val="F2F2F2"/>
+                    </a:solidFill>
+                  </a:tcPr>
+                </a:tc>
+                <a:tc>
+                  <a:txBody>
+                    <a:bodyPr/>
+                    <a:lstStyle/>
+                    <a:p>
+                      <a:pPr algn="r"/>
+                      <a:r>
+                        <a:rPr sz="900" b="1">
+                          <a:solidFill>
+                            <a:srgbClr val="2E7D32"/>
+                          </a:solidFill>
+                          <a:latin typeface="游ゴシック"/>
+                        </a:rPr>
+                        <a:t>＋1.4pt</a:t>
+                      </a:r>
+                    </a:p>
+                  </a:txBody>
+                  <a:tcPr marL="45720" marR="45720" marT="18288" marB="18288" anchor="ctr">
+                    <a:solidFill>
+                      <a:srgbClr val="F2F2F2"/>
+                    </a:solidFill>
+                  </a:tcPr>
+                </a:tc>
+                <a:tc>
+                  <a:txBody>
+                    <a:bodyPr/>
+                    <a:lstStyle/>
+                    <a:p>
+                      <a:pPr algn="r"/>
+                      <a:r>
+                        <a:rPr sz="900" b="0">
+                          <a:solidFill>
+                            <a:srgbClr val="404040"/>
+                          </a:solidFill>
+                          <a:latin typeface="游ゴシック"/>
+                        </a:rPr>
+                        <a:t>886倍</a:t>
+                      </a:r>
+                    </a:p>
+                  </a:txBody>
+                  <a:tcPr marL="45720" marR="45720" marT="18288" marB="18288" anchor="ctr">
+                    <a:solidFill>
+                      <a:srgbClr val="F2F2F2"/>
+                    </a:solidFill>
+                  </a:tcPr>
+                </a:tc>
+                <a:tc>
+                  <a:txBody>
+                    <a:bodyPr/>
+                    <a:lstStyle/>
+                    <a:p>
+                      <a:pPr algn="ctr"/>
+                      <a:r>
+                        <a:rPr sz="900" b="1">
+                          <a:solidFill>
+                            <a:srgbClr val="C00000"/>
+                          </a:solidFill>
+                          <a:latin typeface="游ゴシック"/>
+                        </a:rPr>
+                        <a:t>× 突合のみ</a:t>
+                      </a:r>
+                    </a:p>
+                  </a:txBody>
+                  <a:tcPr marL="45720" marR="45720" marT="18288" marB="18288" anchor="ctr">
+                    <a:solidFill>
+                      <a:srgbClr val="F2F2F2"/>
+                    </a:solidFill>
+                  </a:tcPr>
+                </a:tc>
+              </a:tr>
+              <a:tr h="228600">
+                <a:tc>
+                  <a:txBody>
+                    <a:bodyPr/>
+                    <a:lstStyle/>
+                    <a:p>
+                      <a:pPr algn="l"/>
+                      <a:r>
+                        <a:rPr sz="900" b="0">
+                          <a:solidFill>
+                            <a:srgbClr val="404040"/>
+                          </a:solidFill>
+                          <a:latin typeface="游ゴシック"/>
+                        </a:rPr>
+                        <a:t>シール</a:t>
+                      </a:r>
+                    </a:p>
+                  </a:txBody>
+                  <a:tcPr marL="45720" marR="45720" marT="18288" marB="18288" anchor="ctr">
+                    <a:noFill/>
+                  </a:tcPr>
+                </a:tc>
+                <a:tc>
+                  <a:txBody>
+                    <a:bodyPr/>
+                    <a:lstStyle/>
+                    <a:p>
+                      <a:pPr algn="r"/>
+                      <a:r>
+                        <a:rPr sz="900" b="0">
+                          <a:solidFill>
+                            <a:srgbClr val="404040"/>
+                          </a:solidFill>
+                          <a:latin typeface="游ゴシック"/>
+                        </a:rPr>
+                        <a:t>＋17.7％</a:t>
+                      </a:r>
+                    </a:p>
+                  </a:txBody>
+                  <a:tcPr marL="45720" marR="45720" marT="18288" marB="18288" anchor="ctr">
+                    <a:noFill/>
+                  </a:tcPr>
+                </a:tc>
+                <a:tc>
+                  <a:txBody>
+                    <a:bodyPr/>
+                    <a:lstStyle/>
+                    <a:p>
+                      <a:pPr algn="r"/>
+                      <a:r>
+                        <a:rPr sz="900" b="0">
+                          <a:solidFill>
+                            <a:srgbClr val="404040"/>
+                          </a:solidFill>
+                          <a:latin typeface="游ゴシック"/>
+                        </a:rPr>
+                        <a:t>＋13.4％</a:t>
+                      </a:r>
+                    </a:p>
+                  </a:txBody>
+                  <a:tcPr marL="45720" marR="45720" marT="18288" marB="18288" anchor="ctr">
+                    <a:noFill/>
+                  </a:tcPr>
+                </a:tc>
+                <a:tc>
+                  <a:txBody>
+                    <a:bodyPr/>
+                    <a:lstStyle/>
+                    <a:p>
+                      <a:pPr algn="r"/>
+                      <a:r>
+                        <a:rPr sz="900" b="1">
+                          <a:solidFill>
+                            <a:srgbClr val="2E7D32"/>
+                          </a:solidFill>
+                          <a:latin typeface="游ゴシック"/>
+                        </a:rPr>
+                        <a:t>＋4.3pt</a:t>
+                      </a:r>
+                    </a:p>
+                  </a:txBody>
+                  <a:tcPr marL="45720" marR="45720" marT="18288" marB="18288" anchor="ctr">
+                    <a:noFill/>
+                  </a:tcPr>
+                </a:tc>
+                <a:tc>
+                  <a:txBody>
+                    <a:bodyPr/>
+                    <a:lstStyle/>
+                    <a:p>
+                      <a:pPr algn="r"/>
+                      <a:r>
+                        <a:rPr sz="900" b="0">
+                          <a:solidFill>
+                            <a:srgbClr val="404040"/>
+                          </a:solidFill>
+                          <a:latin typeface="游ゴシック"/>
+                        </a:rPr>
+                        <a:t>2,505倍</a:t>
+                      </a:r>
+                    </a:p>
+                  </a:txBody>
+                  <a:tcPr marL="45720" marR="45720" marT="18288" marB="18288" anchor="ctr">
+                    <a:noFill/>
+                  </a:tcPr>
+                </a:tc>
+                <a:tc>
+                  <a:txBody>
+                    <a:bodyPr/>
+                    <a:lstStyle/>
+                    <a:p>
+                      <a:pPr algn="ctr"/>
+                      <a:r>
+                        <a:rPr sz="900" b="1">
+                          <a:solidFill>
+                            <a:srgbClr val="C00000"/>
+                          </a:solidFill>
+                          <a:latin typeface="游ゴシック"/>
+                        </a:rPr>
+                        <a:t>× 突合のみ</a:t>
+                      </a:r>
+                    </a:p>
+                  </a:txBody>
+                  <a:tcPr marL="45720" marR="45720" marT="18288" marB="18288" anchor="ctr">
+                    <a:noFill/>
+                  </a:tcPr>
+                </a:tc>
+              </a:tr>
+              <a:tr h="228600">
+                <a:tc>
+                  <a:txBody>
+                    <a:bodyPr/>
+                    <a:lstStyle/>
+                    <a:p>
+                      <a:pPr algn="l"/>
+                      <a:r>
+                        <a:rPr sz="900" b="0">
+                          <a:solidFill>
+                            <a:srgbClr val="404040"/>
+                          </a:solidFill>
+                          <a:latin typeface="游ゴシック"/>
+                        </a:rPr>
+                        <a:t>その他</a:t>
+                      </a:r>
+                    </a:p>
+                  </a:txBody>
+                  <a:tcPr marL="45720" marR="45720" marT="18288" marB="18288" anchor="ctr">
+                    <a:solidFill>
+                      <a:srgbClr val="F2F2F2"/>
+                    </a:solidFill>
+                  </a:tcPr>
+                </a:tc>
+                <a:tc>
+                  <a:txBody>
+                    <a:bodyPr/>
+                    <a:lstStyle/>
+                    <a:p>
+                      <a:pPr algn="r"/>
+                      <a:r>
+                        <a:rPr sz="900" b="0">
+                          <a:solidFill>
+                            <a:srgbClr val="404040"/>
+                          </a:solidFill>
+                          <a:latin typeface="游ゴシック"/>
+                        </a:rPr>
+                        <a:t>＋14.0％</a:t>
+                      </a:r>
+                    </a:p>
+                  </a:txBody>
+                  <a:tcPr marL="45720" marR="45720" marT="18288" marB="18288" anchor="ctr">
+                    <a:solidFill>
+                      <a:srgbClr val="F2F2F2"/>
+                    </a:solidFill>
+                  </a:tcPr>
+                </a:tc>
+                <a:tc>
+                  <a:txBody>
+                    <a:bodyPr/>
+                    <a:lstStyle/>
+                    <a:p>
+                      <a:pPr algn="r"/>
+                      <a:r>
+                        <a:rPr sz="900" b="0">
+                          <a:solidFill>
+                            <a:srgbClr val="404040"/>
+                          </a:solidFill>
+                          <a:latin typeface="游ゴシック"/>
+                        </a:rPr>
+                        <a:t>＋18.6％</a:t>
+                      </a:r>
+                    </a:p>
+                  </a:txBody>
+                  <a:tcPr marL="45720" marR="45720" marT="18288" marB="18288" anchor="ctr">
+                    <a:solidFill>
+                      <a:srgbClr val="F2F2F2"/>
+                    </a:solidFill>
+                  </a:tcPr>
+                </a:tc>
+                <a:tc>
+                  <a:txBody>
+                    <a:bodyPr/>
+                    <a:lstStyle/>
+                    <a:p>
+                      <a:pPr algn="r"/>
+                      <a:r>
+                        <a:rPr sz="900" b="1">
+                          <a:solidFill>
+                            <a:srgbClr val="C00000"/>
+                          </a:solidFill>
+                          <a:latin typeface="游ゴシック"/>
+                        </a:rPr>
+                        <a:t>▲4.6pt</a:t>
+                      </a:r>
+                    </a:p>
+                  </a:txBody>
+                  <a:tcPr marL="45720" marR="45720" marT="18288" marB="18288" anchor="ctr">
+                    <a:solidFill>
+                      <a:srgbClr val="F2F2F2"/>
+                    </a:solidFill>
+                  </a:tcPr>
+                </a:tc>
+                <a:tc>
+                  <a:txBody>
+                    <a:bodyPr/>
+                    <a:lstStyle/>
+                    <a:p>
+                      <a:pPr algn="r"/>
+                      <a:r>
+                        <a:rPr sz="900" b="0">
+                          <a:solidFill>
+                            <a:srgbClr val="404040"/>
+                          </a:solidFill>
+                          <a:latin typeface="游ゴシック"/>
+                        </a:rPr>
+                        <a:t>574倍</a:t>
+                      </a:r>
+                    </a:p>
+                  </a:txBody>
+                  <a:tcPr marL="45720" marR="45720" marT="18288" marB="18288" anchor="ctr">
+                    <a:solidFill>
+                      <a:srgbClr val="F2F2F2"/>
+                    </a:solidFill>
+                  </a:tcPr>
+                </a:tc>
+                <a:tc>
+                  <a:txBody>
+                    <a:bodyPr/>
+                    <a:lstStyle/>
+                    <a:p>
+                      <a:pPr algn="ctr"/>
+                      <a:r>
+                        <a:rPr sz="900" b="1">
+                          <a:solidFill>
+                            <a:srgbClr val="C00000"/>
+                          </a:solidFill>
+                          <a:latin typeface="游ゴシック"/>
+                        </a:rPr>
+                        <a:t>× 突合のみ</a:t>
+                      </a:r>
+                    </a:p>
+                  </a:txBody>
+                  <a:tcPr marL="45720" marR="45720" marT="18288" marB="18288" anchor="ctr">
+                    <a:solidFill>
+                      <a:srgbClr val="F2F2F2"/>
+                    </a:solidFill>
+                  </a:tcPr>
+                </a:tc>
+              </a:tr>
+            </a:tbl>
+          </a:graphicData>
+        </a:graphic>
+      </p:graphicFrame>
+      <p:sp>
+        <p:nvSpPr>
+          <p:cNvPr id="16" name="Rectangle 15"/>
+          <p:cNvSpPr/>
+          <p:nvPr/>
+        </p:nvSpPr>
+        <p:spPr>
+          <a:xfrm>
+            <a:off x="411480" y="4434840"/>
+            <a:ext cx="3657600" cy="1554480"/>
+          </a:xfrm>
+          <a:prstGeom prst="rect">
+            <a:avLst/>
+          </a:prstGeom>
+          <a:solidFill>
+            <a:srgbClr val="F7F9FC"/>
+          </a:solidFill>
+          <a:ln>
+            <a:noFill/>
+          </a:ln>
+          <a:effectLst/>
+        </p:spPr>
+        <p:style>
+          <a:lnRef idx="1">
+            <a:schemeClr val="accent1"/>
+          </a:lnRef>
+          <a:fillRef idx="3">
+            <a:schemeClr val="accent1"/>
+          </a:fillRef>
+          <a:effectRef idx="2">
+            <a:schemeClr val="accent1"/>
+          </a:effectRef>
+          <a:fontRef idx="minor">
+            <a:schemeClr val="lt1"/>
+          </a:fontRef>
+        </p:style>
+        <p:txBody>
+          <a:bodyPr rtlCol="0" anchor="ctr"/>
+          <a:lstStyle/>
+          <a:p>
+            <a:pPr algn="ctr"/>
+          </a:p>
+        </p:txBody>
+      </p:sp>
+      <p:sp>
+        <p:nvSpPr>
+          <p:cNvPr id="17" name="TextBox 16"/>
+          <p:cNvSpPr txBox="1"/>
+          <p:nvPr/>
+        </p:nvSpPr>
+        <p:spPr>
+          <a:xfrm>
+            <a:off x="548640" y="4507992"/>
+            <a:ext cx="3383280" cy="1408176"/>
+          </a:xfrm>
+          <a:prstGeom prst="rect">
+            <a:avLst/>
+          </a:prstGeom>
+          <a:noFill/>
+        </p:spPr>
+        <p:txBody>
+          <a:bodyPr wrap="square" lIns="0" rIns="0">
+            <a:spAutoFit/>
+          </a:bodyPr>
+          <a:lstStyle/>
+          <a:p>
+            <a:r>
+              <a:rPr sz="1200" b="1">
+                <a:solidFill>
+                  <a:srgbClr val="B8860B"/>
+                </a:solidFill>
+                <a:latin typeface="游ゴシック"/>
+              </a:rPr>
+              <a:t>① スペック変更の影響は全体で▲2.0pt</a:t>
+            </a:r>
+          </a:p>
+          <a:p>
+            <a:pPr>
+              <a:spcBef>
+                <a:spcPts val="400"/>
+              </a:spcBef>
+            </a:pPr>
+            <a:r>
+              <a:rPr sz="1000" b="0">
+                <a:solidFill>
+                  <a:srgbClr val="404040"/>
+                </a:solidFill>
+                <a:latin typeface="游ゴシック"/>
+              </a:rPr>
+              <a:t>突合＋19.6％に対し、分類別平均単価では＋17.5％。仕様変更や安価品への切替が値上げの一部を相殺している。</a:t>
+            </a:r>
+          </a:p>
+          <a:p>
+            <a:pPr>
+              <a:spcBef>
+                <a:spcPts val="400"/>
+              </a:spcBef>
+            </a:pPr>
+            <a:r>
+              <a:rPr sz="1000" b="1">
+                <a:solidFill>
+                  <a:srgbClr val="1F3864"/>
+                </a:solidFill>
+                <a:latin typeface="游ゴシック"/>
+              </a:rPr>
+              <a:t>→ 計画の単価前提は突合の数字より低めに置く。</a:t>
+            </a:r>
+          </a:p>
+        </p:txBody>
+      </p:sp>
+      <p:sp>
+        <p:nvSpPr>
+          <p:cNvPr id="18" name="Rectangle 17"/>
+          <p:cNvSpPr/>
+          <p:nvPr/>
+        </p:nvSpPr>
+        <p:spPr>
+          <a:xfrm>
+            <a:off x="4251960" y="4434840"/>
+            <a:ext cx="3657600" cy="1554480"/>
+          </a:xfrm>
+          <a:prstGeom prst="rect">
+            <a:avLst/>
+          </a:prstGeom>
+          <a:solidFill>
+            <a:srgbClr val="F7F9FC"/>
+          </a:solidFill>
+          <a:ln>
+            <a:noFill/>
+          </a:ln>
+          <a:effectLst/>
+        </p:spPr>
+        <p:style>
+          <a:lnRef idx="1">
+            <a:schemeClr val="accent1"/>
+          </a:lnRef>
+          <a:fillRef idx="3">
+            <a:schemeClr val="accent1"/>
+          </a:fillRef>
+          <a:effectRef idx="2">
+            <a:schemeClr val="accent1"/>
+          </a:effectRef>
+          <a:fontRef idx="minor">
+            <a:schemeClr val="lt1"/>
+          </a:fontRef>
+        </p:style>
+        <p:txBody>
+          <a:bodyPr rtlCol="0" anchor="ctr"/>
+          <a:lstStyle/>
+          <a:p>
+            <a:pPr algn="ctr"/>
+          </a:p>
+        </p:txBody>
+      </p:sp>
+      <p:sp>
+        <p:nvSpPr>
+          <p:cNvPr id="19" name="TextBox 18"/>
+          <p:cNvSpPr txBox="1"/>
+          <p:nvPr/>
+        </p:nvSpPr>
+        <p:spPr>
+          <a:xfrm>
+            <a:off x="4389120" y="4507992"/>
+            <a:ext cx="3383280" cy="1408176"/>
+          </a:xfrm>
+          <a:prstGeom prst="rect">
+            <a:avLst/>
+          </a:prstGeom>
+          <a:noFill/>
+        </p:spPr>
+        <p:txBody>
+          <a:bodyPr wrap="square" lIns="0" rIns="0">
+            <a:spAutoFit/>
+          </a:bodyPr>
+          <a:lstStyle/>
+          <a:p>
+            <a:r>
+              <a:rPr sz="1200" b="1">
+                <a:solidFill>
+                  <a:srgbClr val="C00000"/>
+                </a:solidFill>
+                <a:latin typeface="游ゴシック"/>
+              </a:rPr>
+              <a:t>② トレーはスペックダウンが大きい</a:t>
+            </a:r>
+          </a:p>
+          <a:p>
+            <a:pPr>
+              <a:spcBef>
+                <a:spcPts val="400"/>
+              </a:spcBef>
+            </a:pPr>
+            <a:r>
+              <a:rPr sz="1000" b="0">
+                <a:solidFill>
+                  <a:srgbClr val="404040"/>
+                </a:solidFill>
+                <a:latin typeface="游ゴシック"/>
+              </a:rPr>
+              <a:t>トレーは突合＋22.5％に対し平均単価＋8.1％で、差▲14.3pt。安価なトレーへの切替・サイズダウンが進んでいる。発泡スチロールは逆に高単価品へシフト（＋16.9pt）。</a:t>
+            </a:r>
+          </a:p>
+        </p:txBody>
+      </p:sp>
+      <p:sp>
+        <p:nvSpPr>
+          <p:cNvPr id="20" name="Rectangle 19"/>
+          <p:cNvSpPr/>
+          <p:nvPr/>
+        </p:nvSpPr>
+        <p:spPr>
+          <a:xfrm>
+            <a:off x="8092440" y="4434840"/>
+            <a:ext cx="3657600" cy="1554480"/>
+          </a:xfrm>
+          <a:prstGeom prst="rect">
+            <a:avLst/>
+          </a:prstGeom>
+          <a:solidFill>
+            <a:srgbClr val="F7F9FC"/>
+          </a:solidFill>
+          <a:ln>
+            <a:noFill/>
+          </a:ln>
+          <a:effectLst/>
+        </p:spPr>
+        <p:style>
+          <a:lnRef idx="1">
+            <a:schemeClr val="accent1"/>
+          </a:lnRef>
+          <a:fillRef idx="3">
+            <a:schemeClr val="accent1"/>
+          </a:fillRef>
+          <a:effectRef idx="2">
+            <a:schemeClr val="accent1"/>
+          </a:effectRef>
+          <a:fontRef idx="minor">
+            <a:schemeClr val="lt1"/>
+          </a:fontRef>
+        </p:style>
+        <p:txBody>
+          <a:bodyPr rtlCol="0" anchor="ctr"/>
+          <a:lstStyle/>
+          <a:p>
+            <a:pPr algn="ctr"/>
+          </a:p>
+        </p:txBody>
+      </p:sp>
+      <p:sp>
+        <p:nvSpPr>
+          <p:cNvPr id="21" name="TextBox 20"/>
+          <p:cNvSpPr txBox="1"/>
+          <p:nvPr/>
+        </p:nvSpPr>
+        <p:spPr>
+          <a:xfrm>
+            <a:off x="8229600" y="4507992"/>
+            <a:ext cx="3383280" cy="1408176"/>
+          </a:xfrm>
+          <a:prstGeom prst="rect">
+            <a:avLst/>
+          </a:prstGeom>
+          <a:noFill/>
+        </p:spPr>
+        <p:txBody>
+          <a:bodyPr wrap="square" lIns="0" rIns="0">
+            <a:spAutoFit/>
+          </a:bodyPr>
+          <a:lstStyle/>
+          <a:p>
+            <a:r>
+              <a:rPr sz="1200" b="1">
+                <a:solidFill>
+                  <a:srgbClr val="4472C4"/>
+                </a:solidFill>
+                <a:latin typeface="游ゴシック"/>
+              </a:rPr>
+              <a:t>③ 使い分け（ハイブリッド）</a:t>
+            </a:r>
+          </a:p>
+          <a:p>
+            <a:pPr>
+              <a:spcBef>
+                <a:spcPts val="400"/>
+              </a:spcBef>
+            </a:pPr>
+            <a:r>
+              <a:rPr sz="1000" b="0">
+                <a:solidFill>
+                  <a:srgbClr val="404040"/>
+                </a:solidFill>
+                <a:latin typeface="游ゴシック"/>
+              </a:rPr>
+              <a:t>単位がそろう分類（トレー・発泡・段ボール等）は平均単価を採用し、スペック変更込みの単価変化とする。</a:t>
+            </a:r>
+          </a:p>
+          <a:p>
+            <a:pPr>
+              <a:spcBef>
+                <a:spcPts val="400"/>
+              </a:spcBef>
+            </a:pPr>
+            <a:r>
+              <a:rPr sz="1000" b="0">
+                <a:solidFill>
+                  <a:srgbClr val="404040"/>
+                </a:solidFill>
+                <a:latin typeface="游ゴシック"/>
+              </a:rPr>
+              <a:t>枚売りとケース売りが混在する分類（袋類・フィルム・シール・その他）は突合で測り、スペック変更分は品目入替（P10）で別建て。</a:t>
             </a:r>
           </a:p>
         </p:txBody>

</xml_diff>